<commit_message>
docs: remove third slide from interview deck
</commit_message>
<xml_diff>
--- a/识价镜_Agent_技术面试演示_黑金模板版.pptx
+++ b/识价镜_Agent_技术面试演示_黑金模板版.pptx
@@ -2,15 +2,14 @@
 <file path=ppt/presentation.xml><?xml version="1.0" encoding="utf-8"?>
 <p:presentation xmlns:p="http://schemas.openxmlformats.org/presentationml/2006/main">
   <p:sldMasterIdLst>
-    <p:sldMasterId xmlns:r="http://schemas.openxmlformats.org/officeDocument/2006/relationships" id="2147483648" r:id="Rec2c1059e2444be5"/>
+    <p:sldMasterId xmlns:r="http://schemas.openxmlformats.org/officeDocument/2006/relationships" id="2147483648" r:id="R3900f8e8f1964f2b"/>
   </p:sldMasterIdLst>
   <p:notesMasterIdLst>
-    <p:notesMasterId xmlns:r="http://schemas.openxmlformats.org/officeDocument/2006/relationships" r:id="R05a15f710dd34345"/>
+    <p:notesMasterId xmlns:r="http://schemas.openxmlformats.org/officeDocument/2006/relationships" r:id="R8aa2f9b7068b403c"/>
   </p:notesMasterIdLst>
   <p:sldIdLst>
-    <p:sldId xmlns:r="http://schemas.openxmlformats.org/officeDocument/2006/relationships" id="256" r:id="R822e6edc4a984e05"/>
-    <p:sldId xmlns:r="http://schemas.openxmlformats.org/officeDocument/2006/relationships" id="257" r:id="R927c4e39745c4096"/>
-    <p:sldId xmlns:r="http://schemas.openxmlformats.org/officeDocument/2006/relationships" id="258" r:id="Rc184301b7ae34107"/>
+    <p:sldId xmlns:r="http://schemas.openxmlformats.org/officeDocument/2006/relationships" id="256" r:id="R4d9c06456d194175"/>
+    <p:sldId xmlns:r="http://schemas.openxmlformats.org/officeDocument/2006/relationships" id="257" r:id="R0fd6e79c5a0342b8"/>
   </p:sldIdLst>
   <p:sldSz cx="12192000" cy="6858000"/>
   <p:notesSz cx="6858000" cy="9144000"/>
@@ -530,106 +529,6 @@
 </p:notes>
 </file>
 
-<file path=ppt/notesSlides/notesSlide3.xml><?xml version="1.0" encoding="utf-8"?>
-<p:notes xmlns:p="http://schemas.openxmlformats.org/presentationml/2006/main">
-  <p:cSld>
-    <p:spTree>
-      <p:nvGrpSpPr>
-        <p:cNvPr id="1" name=""/>
-        <p:cNvGrpSpPr/>
-        <p:nvPr/>
-      </p:nvGrpSpPr>
-      <p:grpSpPr>
-        <a:xfrm xmlns:a="http://schemas.openxmlformats.org/drawingml/2006/main"/>
-      </p:grpSpPr>
-      <p:sp>
-        <p:nvSpPr>
-          <p:cNvPr id="2" name="Slide Image Placeholder 1"/>
-          <p:cNvSpPr>
-            <a:spLocks xmlns:a="http://schemas.openxmlformats.org/drawingml/2006/main" noGrp="1"/>
-          </p:cNvSpPr>
-          <p:nvPr>
-            <p:ph type="sldImg" idx="0"/>
-          </p:nvPr>
-        </p:nvSpPr>
-        <p:spPr/>
-      </p:sp>
-      <p:sp>
-        <p:nvSpPr>
-          <p:cNvPr id="3" name="Notes Placeholder 2"/>
-          <p:cNvSpPr>
-            <a:spLocks xmlns:a="http://schemas.openxmlformats.org/drawingml/2006/main" noGrp="1"/>
-          </p:cNvSpPr>
-          <p:nvPr>
-            <p:ph type="body" idx="1"/>
-          </p:nvPr>
-        </p:nvSpPr>
-        <p:spPr/>
-        <p:txBody>
-          <a:bodyPr xmlns:a="http://schemas.openxmlformats.org/drawingml/2006/main"/>
-          <a:lstStyle xmlns:a="http://schemas.openxmlformats.org/drawingml/2006/main"/>
-          <a:p xmlns:a="http://schemas.openxmlformats.org/drawingml/2006/main">
-            <a:r>
-              <a:t>核心问题：相似图不等于同款商品，只有确定可比较对象后价格比较才有意义。</a:t>
-            </a:r>
-          </a:p>
-          <a:p xmlns:a="http://schemas.openxmlformats.org/drawingml/2006/main">
-            <a:r>
-              <a:t/>
-            </a:r>
-          </a:p>
-          <a:p xmlns:a="http://schemas.openxmlformats.org/drawingml/2006/main">
-            <a:r>
-              <a:t>[Sources]</a:t>
-            </a:r>
-          </a:p>
-          <a:p xmlns:a="http://schemas.openxmlformats.org/drawingml/2006/main">
-            <a:r>
-              <a:t>- D:\实习\简历\output\pdf\张思成_简历.pdf</a:t>
-            </a:r>
-          </a:p>
-          <a:p xmlns:a="http://schemas.openxmlformats.org/drawingml/2006/main">
-            <a:r>
-              <a:t>- D:\E.C.26-B\src\shijiajing_agent\contracts.py</a:t>
-            </a:r>
-          </a:p>
-          <a:p xmlns:a="http://schemas.openxmlformats.org/drawingml/2006/main">
-            <a:r>
-              <a:t>- D:\E.C.26-B\docs\architecture.md</a:t>
-            </a:r>
-          </a:p>
-          <a:p xmlns:a="http://schemas.openxmlformats.org/drawingml/2006/main">
-            <a:r>
-              <a:t>[/Sources]</a:t>
-            </a:r>
-          </a:p>
-        </p:txBody>
-      </p:sp>
-      <p:sp>
-        <p:nvSpPr>
-          <p:cNvPr id="4" name="Slide Number Placeholder 3"/>
-          <p:cNvSpPr>
-            <a:spLocks xmlns:a="http://schemas.openxmlformats.org/drawingml/2006/main" noGrp="1"/>
-          </p:cNvSpPr>
-          <p:nvPr>
-            <p:ph type="sldNum" idx="5"/>
-          </p:nvPr>
-        </p:nvSpPr>
-        <p:spPr/>
-        <p:txBody>
-          <a:bodyPr xmlns:a="http://schemas.openxmlformats.org/drawingml/2006/main"/>
-          <a:lstStyle xmlns:a="http://schemas.openxmlformats.org/drawingml/2006/main"/>
-          <a:p xmlns:a="http://schemas.openxmlformats.org/drawingml/2006/main"/>
-        </p:txBody>
-      </p:sp>
-    </p:spTree>
-  </p:cSld>
-  <p:clrMapOvr>
-    <a:masterClrMapping xmlns:a="http://schemas.openxmlformats.org/drawingml/2006/main"/>
-  </p:clrMapOvr>
-</p:notes>
-</file>
-
 <file path=ppt/slideLayouts/slideLayout1.xml><?xml version="1.0" encoding="utf-8"?>
 <p:sldLayout xmlns:p="http://schemas.openxmlformats.org/presentationml/2006/main" type="obj" preserve="1">
   <p:cSld name="标题和内容">
@@ -855,7 +754,7 @@
           <p:nvPr/>
         </p:nvPicPr>
         <p:blipFill>
-          <a:blip xmlns:r="http://schemas.openxmlformats.org/officeDocument/2006/relationships" xmlns:a="http://schemas.openxmlformats.org/drawingml/2006/main" r:embed="R0519c6e3c963467c"/>
+          <a:blip xmlns:r="http://schemas.openxmlformats.org/officeDocument/2006/relationships" xmlns:a="http://schemas.openxmlformats.org/drawingml/2006/main" r:embed="Rd69bf00caa8747d5"/>
           <a:srcRect xmlns:a="http://schemas.openxmlformats.org/drawingml/2006/main" l="0" t="0" r="39" b="0"/>
           <a:stretch xmlns:a="http://schemas.openxmlformats.org/drawingml/2006/main">
             <a:fillRect l="0" t="0" r="0" b="0"/>
@@ -1361,7 +1260,7 @@
           <p:nvPr/>
         </p:nvPicPr>
         <p:blipFill>
-          <a:blip xmlns:r="http://schemas.openxmlformats.org/officeDocument/2006/relationships" xmlns:a="http://schemas.openxmlformats.org/drawingml/2006/main" r:embed="Red6d688ead5e4ee3"/>
+          <a:blip xmlns:r="http://schemas.openxmlformats.org/officeDocument/2006/relationships" xmlns:a="http://schemas.openxmlformats.org/drawingml/2006/main" r:embed="Rd566d0ffcb29459a"/>
           <a:srcRect xmlns:a="http://schemas.openxmlformats.org/drawingml/2006/main" l="0" t="0" r="39" b="0"/>
           <a:stretch xmlns:a="http://schemas.openxmlformats.org/drawingml/2006/main">
             <a:fillRect l="0" t="0" r="0" b="0"/>
@@ -4672,7 +4571,7 @@
           <p:nvPr/>
         </p:nvPicPr>
         <p:blipFill>
-          <a:blip xmlns:r="http://schemas.openxmlformats.org/officeDocument/2006/relationships" xmlns:a="http://schemas.openxmlformats.org/drawingml/2006/main" r:embed="R729103086b234305"/>
+          <a:blip xmlns:r="http://schemas.openxmlformats.org/officeDocument/2006/relationships" xmlns:a="http://schemas.openxmlformats.org/drawingml/2006/main" r:embed="R94b5a03229434850"/>
           <a:srcRect xmlns:a="http://schemas.openxmlformats.org/drawingml/2006/main" l="0" t="0" r="39" b="0"/>
           <a:stretch xmlns:a="http://schemas.openxmlformats.org/drawingml/2006/main">
             <a:fillRect l="0" t="0" r="0" b="0"/>
@@ -5250,7 +5149,7 @@
           <p:nvPr/>
         </p:nvPicPr>
         <p:blipFill>
-          <a:blip xmlns:r="http://schemas.openxmlformats.org/officeDocument/2006/relationships" xmlns:a="http://schemas.openxmlformats.org/drawingml/2006/main" r:embed="R0dcd427deaf744f8"/>
+          <a:blip xmlns:r="http://schemas.openxmlformats.org/officeDocument/2006/relationships" xmlns:a="http://schemas.openxmlformats.org/drawingml/2006/main" r:embed="R6537900708134468"/>
           <a:srcRect xmlns:a="http://schemas.openxmlformats.org/drawingml/2006/main" l="0" t="0" r="39" b="0"/>
           <a:stretch xmlns:a="http://schemas.openxmlformats.org/drawingml/2006/main">
             <a:fillRect l="0" t="0" r="0" b="0"/>
@@ -5906,18 +5805,18 @@
   </p:cSld>
   <p:clrMap bg1="dk1" tx1="lt1" bg2="dk2" tx2="lt2" accent1="accent1" accent2="accent2" accent3="accent3" accent4="accent4" accent5="accent5" accent6="accent6" hlink="hlink" folHlink="folHlink"/>
   <p:sldLayoutIdLst>
-    <p:sldLayoutId xmlns:r="http://schemas.openxmlformats.org/officeDocument/2006/relationships" id="2147483649" r:id="R14a4437234884ef0"/>
-    <p:sldLayoutId xmlns:r="http://schemas.openxmlformats.org/officeDocument/2006/relationships" id="2147483650" r:id="Rd7e709f0f8ad4684"/>
-    <p:sldLayoutId xmlns:r="http://schemas.openxmlformats.org/officeDocument/2006/relationships" id="2147483651" r:id="R8ffa080493744d2b"/>
-    <p:sldLayoutId xmlns:r="http://schemas.openxmlformats.org/officeDocument/2006/relationships" id="2147483652" r:id="Rdb7b110c143e4fbe"/>
-    <p:sldLayoutId xmlns:r="http://schemas.openxmlformats.org/officeDocument/2006/relationships" id="2147483653" r:id="R0e6d4d653031423f"/>
-    <p:sldLayoutId xmlns:r="http://schemas.openxmlformats.org/officeDocument/2006/relationships" id="2147483654" r:id="R19ce52b3cd214eca"/>
-    <p:sldLayoutId xmlns:r="http://schemas.openxmlformats.org/officeDocument/2006/relationships" id="2147483655" r:id="R6fb5575260044f5c"/>
-    <p:sldLayoutId xmlns:r="http://schemas.openxmlformats.org/officeDocument/2006/relationships" id="2147483656" r:id="Re5cb31cc1aeb494c"/>
-    <p:sldLayoutId xmlns:r="http://schemas.openxmlformats.org/officeDocument/2006/relationships" id="2147483657" r:id="R1350d8cef1654dc0"/>
-    <p:sldLayoutId xmlns:r="http://schemas.openxmlformats.org/officeDocument/2006/relationships" id="2147483658" r:id="R878e5ab26d2244e3"/>
-    <p:sldLayoutId xmlns:r="http://schemas.openxmlformats.org/officeDocument/2006/relationships" id="2147483659" r:id="R00ae445272e447f0"/>
-    <p:sldLayoutId xmlns:r="http://schemas.openxmlformats.org/officeDocument/2006/relationships" id="2147483660" r:id="R1f48c6337e7b48a9"/>
+    <p:sldLayoutId xmlns:r="http://schemas.openxmlformats.org/officeDocument/2006/relationships" id="2147483649" r:id="R6a232b08e344448d"/>
+    <p:sldLayoutId xmlns:r="http://schemas.openxmlformats.org/officeDocument/2006/relationships" id="2147483650" r:id="Rbdbfb65af35e40ce"/>
+    <p:sldLayoutId xmlns:r="http://schemas.openxmlformats.org/officeDocument/2006/relationships" id="2147483651" r:id="R8086fe0a2b414f4b"/>
+    <p:sldLayoutId xmlns:r="http://schemas.openxmlformats.org/officeDocument/2006/relationships" id="2147483652" r:id="R6ad8b82ba8894ab0"/>
+    <p:sldLayoutId xmlns:r="http://schemas.openxmlformats.org/officeDocument/2006/relationships" id="2147483653" r:id="R9b35321b8551423a"/>
+    <p:sldLayoutId xmlns:r="http://schemas.openxmlformats.org/officeDocument/2006/relationships" id="2147483654" r:id="R7fbf79bd9faf42c0"/>
+    <p:sldLayoutId xmlns:r="http://schemas.openxmlformats.org/officeDocument/2006/relationships" id="2147483655" r:id="R004cdba36c834db1"/>
+    <p:sldLayoutId xmlns:r="http://schemas.openxmlformats.org/officeDocument/2006/relationships" id="2147483656" r:id="R2c69bb9d6def45fa"/>
+    <p:sldLayoutId xmlns:r="http://schemas.openxmlformats.org/officeDocument/2006/relationships" id="2147483657" r:id="Ra8fd9ff9b56044dc"/>
+    <p:sldLayoutId xmlns:r="http://schemas.openxmlformats.org/officeDocument/2006/relationships" id="2147483658" r:id="R357337961a3a40ef"/>
+    <p:sldLayoutId xmlns:r="http://schemas.openxmlformats.org/officeDocument/2006/relationships" id="2147483659" r:id="R3f13b2a8d9634786"/>
+    <p:sldLayoutId xmlns:r="http://schemas.openxmlformats.org/officeDocument/2006/relationships" id="2147483660" r:id="R404e404bd4e44e4e"/>
   </p:sldLayoutIdLst>
   <p:txStyles>
     <p:titleStyle>
@@ -8219,3426 +8118,6 @@
 </p:sld>
 </file>
 
-<file path=ppt/slides/slide3.xml><?xml version="1.0" encoding="utf-8"?>
-<p:sld xmlns:p="http://schemas.openxmlformats.org/presentationml/2006/main">
-  <p:cSld>
-    <p:spTree>
-      <p:nvGrpSpPr>
-        <p:cNvPr id="1" name=""/>
-        <p:cNvGrpSpPr/>
-        <p:nvPr/>
-      </p:nvGrpSpPr>
-      <p:grpSpPr>
-        <a:xfrm xmlns:a="http://schemas.openxmlformats.org/drawingml/2006/main"/>
-      </p:grpSpPr>
-      <p:sp>
-        <p:nvSpPr>
-          <p:cNvPr id="3" name="文本框 2">
-            <a:extLst xmlns:a="http://schemas.openxmlformats.org/drawingml/2006/main">
-              <a:ext uri="{FF2B5EF4-FFF2-40B4-BE49-F238E27FC236}">
-                <a16:creationId xmlns:a16="http://schemas.microsoft.com/office/drawing/2014/main" id="{6CC809C5-11F5-48B5-842B-679FA1B0EACC}"/>
-              </a:ext>
-            </a:extLst>
-          </p:cNvPr>
-          <p:cNvSpPr>
-            <a:spLocks xmlns:a="http://schemas.openxmlformats.org/drawingml/2006/main" noGrp="1"/>
-          </p:cNvSpPr>
-          <p:nvPr/>
-        </p:nvSpPr>
-        <p:spPr>
-          <a:xfrm xmlns:a="http://schemas.openxmlformats.org/drawingml/2006/main">
-            <a:off x="533400" y="357188"/>
-            <a:ext cx="11125200" cy="500063"/>
-          </a:xfrm>
-          <a:prstGeom xmlns:a="http://schemas.openxmlformats.org/drawingml/2006/main" prst="rect">
-            <a:avLst/>
-          </a:prstGeom>
-          <a:noFill xmlns:a="http://schemas.openxmlformats.org/drawingml/2006/main"/>
-        </p:spPr>
-        <p:txBody>
-          <a:bodyPr xmlns:a="http://schemas.openxmlformats.org/drawingml/2006/main" wrap="square" lIns="0" tIns="0" rIns="0" bIns="0" anchor="t">
-            <a:noAutofit/>
-          </a:bodyPr>
-          <a:lstStyle xmlns:a="http://schemas.openxmlformats.org/drawingml/2006/main"/>
-          <a:p xmlns:a="http://schemas.openxmlformats.org/drawingml/2006/main">
-            <a:pPr algn="l">
-              <a:lnSpc>
-                <a:spcPct val="100000"/>
-              </a:lnSpc>
-              <a:buNone/>
-            </a:pPr>
-            <a:r>
-              <a:rPr sz="3000" b="1">
-                <a:solidFill>
-                  <a:srgbClr val="F4F4F5"/>
-                </a:solidFill>
-                <a:latin typeface="Microsoft YaHei"/>
-                <a:ea typeface="Microsoft YaHei"/>
-                <a:cs typeface="Microsoft YaHei"/>
-              </a:rPr>
-              <a:t>不是找相似图，而是确定可比较对象</a:t>
-            </a:r>
-            <a:endParaRPr sz="3000" b="1">
-              <a:solidFill>
-                <a:srgbClr val="F4F4F5"/>
-              </a:solidFill>
-              <a:latin typeface="Microsoft YaHei"/>
-              <a:ea typeface="Microsoft YaHei"/>
-              <a:cs typeface="Microsoft YaHei"/>
-            </a:endParaRPr>
-          </a:p>
-        </p:txBody>
-      </p:sp>
-      <p:sp>
-        <p:nvSpPr>
-          <p:cNvPr id="4" name="任意多边形 3">
-            <a:extLst xmlns:a="http://schemas.openxmlformats.org/drawingml/2006/main">
-              <a:ext uri="{FF2B5EF4-FFF2-40B4-BE49-F238E27FC236}">
-                <a16:creationId xmlns:a16="http://schemas.microsoft.com/office/drawing/2014/main" id="{A834284C-63F4-478B-B3F1-71196238632E}"/>
-              </a:ext>
-            </a:extLst>
-          </p:cNvPr>
-          <p:cNvSpPr>
-            <a:spLocks xmlns:a="http://schemas.openxmlformats.org/drawingml/2006/main" noGrp="1"/>
-          </p:cNvSpPr>
-          <p:nvPr/>
-        </p:nvSpPr>
-        <p:spPr>
-          <a:xfrm xmlns:a="http://schemas.openxmlformats.org/drawingml/2006/main">
-            <a:off x="575945" y="1109345"/>
-            <a:ext cx="5400675" cy="4090035"/>
-          </a:xfrm>
-          <a:custGeom xmlns:a="http://schemas.openxmlformats.org/drawingml/2006/main">
-            <a:gdLst>
-              <a:gd name="sw" fmla="*/ 1 w 8505"/>
-              <a:gd name="sh" fmla="*/ 1 h 6440"/>
-              <a:gd name="mins" fmla="min sw sh"/>
-              <a:gd name="dsw" fmla="+- 0 sw mins"/>
-              <a:gd name="dsh" fmla="+- 0 sh mins"/>
-              <a:gd name="p0x0" fmla="*/ 120 w 8505"/>
-              <a:gd name="p0y0" fmla="*/ 0 h 6440"/>
-              <a:gd name="p0x1" fmla="*/ 8385 w 8505"/>
-              <a:gd name="p0y1" fmla="*/ 0 h 6440"/>
-              <a:gd name="p0x2" fmla="*/ 8451 w 8505"/>
-              <a:gd name="p0y2" fmla="*/ 0 h 6440"/>
-              <a:gd name="p0x3" fmla="*/ 8505 w 8505"/>
-              <a:gd name="p0y3" fmla="*/ 53 h 6440"/>
-              <a:gd name="p0x4" fmla="*/ 8505 w 8505"/>
-              <a:gd name="p0y4" fmla="*/ 120 h 6440"/>
-              <a:gd name="p0x5" fmla="*/ 8505 w 8505"/>
-              <a:gd name="p0y5" fmla="*/ 6320 h 6440"/>
-              <a:gd name="p0x6" fmla="*/ 8505 w 8505"/>
-              <a:gd name="p0y6" fmla="*/ 6387 h 6440"/>
-              <a:gd name="p0x7" fmla="*/ 8451 w 8505"/>
-              <a:gd name="p0y7" fmla="*/ 6440 h 6440"/>
-              <a:gd name="p0x8" fmla="*/ 8385 w 8505"/>
-              <a:gd name="p0y8" fmla="*/ 6440 h 6440"/>
-              <a:gd name="p0x9" fmla="*/ 120 w 8505"/>
-              <a:gd name="p0y9" fmla="*/ 6440 h 6440"/>
-              <a:gd name="p0x10" fmla="*/ 53 w 8505"/>
-              <a:gd name="p0y10" fmla="*/ 6440 h 6440"/>
-              <a:gd name="p0x11" fmla="*/ 0 w 8505"/>
-              <a:gd name="p0y11" fmla="*/ 6387 h 6440"/>
-              <a:gd name="p0x12" fmla="*/ 0 w 8505"/>
-              <a:gd name="p0y12" fmla="*/ 6320 h 6440"/>
-              <a:gd name="p0x13" fmla="*/ 0 w 8505"/>
-              <a:gd name="p0y13" fmla="*/ 120 h 6440"/>
-              <a:gd name="p0x14" fmla="*/ 0 w 8505"/>
-              <a:gd name="p0y14" fmla="*/ 53 h 6440"/>
-              <a:gd name="p0x15" fmla="*/ 53 w 8505"/>
-              <a:gd name="p0y15" fmla="*/ 0 h 6440"/>
-              <a:gd name="p0x16" fmla="*/ 120 w 8505"/>
-              <a:gd name="p0y16" fmla="*/ 0 h 6440"/>
-            </a:gdLst>
-            <a:pathLst>
-              <a:path w="0" h="0">
-                <a:moveTo>
-                  <a:pt x="0" y="0"/>
-                </a:moveTo>
-                <a:lnTo>
-                  <a:pt x="0" y="0"/>
-                </a:lnTo>
-                <a:cubicBezTo>
-                  <a:pt x="0" y="0"/>
-                  <a:pt x="0" y="0"/>
-                  <a:pt x="0" y="0"/>
-                </a:cubicBezTo>
-                <a:lnTo>
-                  <a:pt x="0" y="0"/>
-                </a:lnTo>
-                <a:cubicBezTo>
-                  <a:pt x="0" y="0"/>
-                  <a:pt x="0" y="0"/>
-                  <a:pt x="0" y="0"/>
-                </a:cubicBezTo>
-                <a:lnTo>
-                  <a:pt x="0" y="0"/>
-                </a:lnTo>
-                <a:cubicBezTo>
-                  <a:pt x="0" y="0"/>
-                  <a:pt x="0" y="0"/>
-                  <a:pt x="0" y="0"/>
-                </a:cubicBezTo>
-                <a:lnTo>
-                  <a:pt x="0" y="0"/>
-                </a:lnTo>
-                <a:cubicBezTo>
-                  <a:pt x="0" y="0"/>
-                  <a:pt x="0" y="0"/>
-                  <a:pt x="0" y="0"/>
-                </a:cubicBezTo>
-                <a:close/>
-              </a:path>
-            </a:pathLst>
-          </a:custGeom>
-          <a:solidFill xmlns:a="http://schemas.openxmlformats.org/drawingml/2006/main">
-            <a:srgbClr val="FFFFFF">
-              <a:alpha val="10980"/>
-            </a:srgbClr>
-          </a:solidFill>
-          <a:ln xmlns:a="http://schemas.openxmlformats.org/drawingml/2006/main" w="9525" cmpd="sng">
-            <a:solidFill>
-              <a:srgbClr val="FFFFFF">
-                <a:alpha val="10980"/>
-              </a:srgbClr>
-            </a:solidFill>
-            <a:prstDash val="solid"/>
-          </a:ln>
-          <a:effectLst xmlns:a="http://schemas.openxmlformats.org/drawingml/2006/main">
-            <a:outerShdw blurRad="142875" algn="ctr" rotWithShape="0">
-              <a:schemeClr val="accent2">
-                <a:alpha val="12157"/>
-              </a:schemeClr>
-            </a:outerShdw>
-          </a:effectLst>
-        </p:spPr>
-        <p:style>
-          <a:lnRef xmlns:a="http://schemas.openxmlformats.org/drawingml/2006/main" idx="2">
-            <a:schemeClr val="accent1">
-              <a:lumMod val="75000"/>
-            </a:schemeClr>
-          </a:lnRef>
-          <a:fillRef xmlns:a="http://schemas.openxmlformats.org/drawingml/2006/main" idx="1">
-            <a:schemeClr val="accent1"/>
-          </a:fillRef>
-          <a:effectRef xmlns:a="http://schemas.openxmlformats.org/drawingml/2006/main" idx="0">
-            <a:srgbClr val="FFFFFF"/>
-          </a:effectRef>
-          <a:fontRef xmlns:a="http://schemas.openxmlformats.org/drawingml/2006/main" idx="minor">
-            <a:schemeClr val="lt1"/>
-          </a:fontRef>
-        </p:style>
-        <p:txBody>
-          <a:bodyPr xmlns:a="http://schemas.openxmlformats.org/drawingml/2006/main" anchor="ctr"/>
-          <a:lstStyle xmlns:a="http://schemas.openxmlformats.org/drawingml/2006/main"/>
-          <a:p xmlns:a="http://schemas.openxmlformats.org/drawingml/2006/main">
-            <a:pPr algn="ctr">
-              <a:buNone/>
-            </a:pPr>
-            <a:endParaRPr/>
-          </a:p>
-        </p:txBody>
-      </p:sp>
-      <p:sp>
-        <p:nvSpPr>
-          <p:cNvPr id="5" name="文本框 4">
-            <a:extLst xmlns:a="http://schemas.openxmlformats.org/drawingml/2006/main">
-              <a:ext uri="{FF2B5EF4-FFF2-40B4-BE49-F238E27FC236}">
-                <a16:creationId xmlns:a16="http://schemas.microsoft.com/office/drawing/2014/main" id="{CE243B75-A665-4385-BFFD-04E50778A3D4}"/>
-              </a:ext>
-            </a:extLst>
-          </p:cNvPr>
-          <p:cNvSpPr>
-            <a:spLocks xmlns:a="http://schemas.openxmlformats.org/drawingml/2006/main" noGrp="1"/>
-          </p:cNvSpPr>
-          <p:nvPr/>
-        </p:nvSpPr>
-        <p:spPr>
-          <a:xfrm xmlns:a="http://schemas.openxmlformats.org/drawingml/2006/main">
-            <a:off x="771525" y="1288732"/>
-            <a:ext cx="5010150" cy="365760"/>
-          </a:xfrm>
-          <a:prstGeom xmlns:a="http://schemas.openxmlformats.org/drawingml/2006/main" prst="rect">
-            <a:avLst/>
-          </a:prstGeom>
-          <a:noFill xmlns:a="http://schemas.openxmlformats.org/drawingml/2006/main"/>
-        </p:spPr>
-        <p:txBody>
-          <a:bodyPr xmlns:a="http://schemas.openxmlformats.org/drawingml/2006/main" wrap="square" lIns="0" tIns="0" rIns="0" bIns="0" anchor="t">
-            <a:noAutofit/>
-          </a:bodyPr>
-          <a:lstStyle xmlns:a="http://schemas.openxmlformats.org/drawingml/2006/main"/>
-          <a:p xmlns:a="http://schemas.openxmlformats.org/drawingml/2006/main">
-            <a:pPr algn="l">
-              <a:lnSpc>
-                <a:spcPct val="104000"/>
-              </a:lnSpc>
-              <a:buNone/>
-            </a:pPr>
-            <a:r>
-              <a:rPr sz="2100" b="1" spc="42">
-                <a:solidFill>
-                  <a:srgbClr val="F4F4F5"/>
-                </a:solidFill>
-                <a:latin typeface="Microsoft YaHei"/>
-                <a:ea typeface="Microsoft YaHei"/>
-                <a:cs typeface="Microsoft YaHei"/>
-              </a:rPr>
-              <a:t>为什么普通图搜不够</a:t>
-            </a:r>
-            <a:endParaRPr sz="2100" b="1" spc="42">
-              <a:solidFill>
-                <a:srgbClr val="F4F4F5"/>
-              </a:solidFill>
-              <a:latin typeface="Microsoft YaHei"/>
-              <a:ea typeface="Microsoft YaHei"/>
-              <a:cs typeface="Microsoft YaHei"/>
-            </a:endParaRPr>
-          </a:p>
-        </p:txBody>
-      </p:sp>
-      <p:sp>
-        <p:nvSpPr>
-          <p:cNvPr id="6" name="任意多边形 5">
-            <a:extLst xmlns:a="http://schemas.openxmlformats.org/drawingml/2006/main">
-              <a:ext uri="{FF2B5EF4-FFF2-40B4-BE49-F238E27FC236}">
-                <a16:creationId xmlns:a16="http://schemas.microsoft.com/office/drawing/2014/main" id="{32BDD4D5-607F-48E0-AAB2-D34BCC5846E6}"/>
-              </a:ext>
-            </a:extLst>
-          </p:cNvPr>
-          <p:cNvSpPr>
-            <a:spLocks xmlns:a="http://schemas.openxmlformats.org/drawingml/2006/main" noGrp="1"/>
-          </p:cNvSpPr>
-          <p:nvPr/>
-        </p:nvSpPr>
-        <p:spPr>
-          <a:xfrm xmlns:a="http://schemas.openxmlformats.org/drawingml/2006/main">
-            <a:off x="771525" y="1835785"/>
-            <a:ext cx="342900" cy="342900"/>
-          </a:xfrm>
-          <a:custGeom xmlns:a="http://schemas.openxmlformats.org/drawingml/2006/main">
-            <a:gdLst>
-              <a:gd name="sw" fmla="*/ 1 w 540"/>
-              <a:gd name="sh" fmla="*/ 1 h 540"/>
-              <a:gd name="mins" fmla="min sw sh"/>
-              <a:gd name="dsw" fmla="+- 0 sw mins"/>
-              <a:gd name="dsh" fmla="+- 0 sh mins"/>
-              <a:gd name="p0x0" fmla="*/ 120 w 540"/>
-              <a:gd name="p0y0" fmla="*/ 0 h 540"/>
-              <a:gd name="p0x1" fmla="*/ 420 w 540"/>
-              <a:gd name="p0y1" fmla="*/ 0 h 540"/>
-              <a:gd name="p0x2" fmla="*/ 486 w 540"/>
-              <a:gd name="p0y2" fmla="*/ 0 h 540"/>
-              <a:gd name="p0x3" fmla="*/ 540 w 540"/>
-              <a:gd name="p0y3" fmla="*/ 53 h 540"/>
-              <a:gd name="p0x4" fmla="*/ 540 w 540"/>
-              <a:gd name="p0y4" fmla="*/ 120 h 540"/>
-              <a:gd name="p0x5" fmla="*/ 540 w 540"/>
-              <a:gd name="p0y5" fmla="*/ 420 h 540"/>
-              <a:gd name="p0x6" fmla="*/ 540 w 540"/>
-              <a:gd name="p0y6" fmla="*/ 486 h 540"/>
-              <a:gd name="p0x7" fmla="*/ 486 w 540"/>
-              <a:gd name="p0y7" fmla="*/ 540 h 540"/>
-              <a:gd name="p0x8" fmla="*/ 420 w 540"/>
-              <a:gd name="p0y8" fmla="*/ 540 h 540"/>
-              <a:gd name="p0x9" fmla="*/ 120 w 540"/>
-              <a:gd name="p0y9" fmla="*/ 540 h 540"/>
-              <a:gd name="p0x10" fmla="*/ 53 w 540"/>
-              <a:gd name="p0y10" fmla="*/ 540 h 540"/>
-              <a:gd name="p0x11" fmla="*/ 0 w 540"/>
-              <a:gd name="p0y11" fmla="*/ 486 h 540"/>
-              <a:gd name="p0x12" fmla="*/ 0 w 540"/>
-              <a:gd name="p0y12" fmla="*/ 420 h 540"/>
-              <a:gd name="p0x13" fmla="*/ 0 w 540"/>
-              <a:gd name="p0y13" fmla="*/ 120 h 540"/>
-              <a:gd name="p0x14" fmla="*/ 0 w 540"/>
-              <a:gd name="p0y14" fmla="*/ 53 h 540"/>
-              <a:gd name="p0x15" fmla="*/ 53 w 540"/>
-              <a:gd name="p0y15" fmla="*/ 0 h 540"/>
-              <a:gd name="p0x16" fmla="*/ 120 w 540"/>
-              <a:gd name="p0y16" fmla="*/ 0 h 540"/>
-            </a:gdLst>
-            <a:pathLst>
-              <a:path w="0" h="0">
-                <a:moveTo>
-                  <a:pt x="0" y="0"/>
-                </a:moveTo>
-                <a:lnTo>
-                  <a:pt x="0" y="0"/>
-                </a:lnTo>
-                <a:cubicBezTo>
-                  <a:pt x="0" y="0"/>
-                  <a:pt x="0" y="0"/>
-                  <a:pt x="0" y="0"/>
-                </a:cubicBezTo>
-                <a:lnTo>
-                  <a:pt x="0" y="0"/>
-                </a:lnTo>
-                <a:cubicBezTo>
-                  <a:pt x="0" y="0"/>
-                  <a:pt x="0" y="0"/>
-                  <a:pt x="0" y="0"/>
-                </a:cubicBezTo>
-                <a:lnTo>
-                  <a:pt x="0" y="0"/>
-                </a:lnTo>
-                <a:cubicBezTo>
-                  <a:pt x="0" y="0"/>
-                  <a:pt x="0" y="0"/>
-                  <a:pt x="0" y="0"/>
-                </a:cubicBezTo>
-                <a:lnTo>
-                  <a:pt x="0" y="0"/>
-                </a:lnTo>
-                <a:cubicBezTo>
-                  <a:pt x="0" y="0"/>
-                  <a:pt x="0" y="0"/>
-                  <a:pt x="0" y="0"/>
-                </a:cubicBezTo>
-                <a:close/>
-              </a:path>
-            </a:pathLst>
-          </a:custGeom>
-          <a:solidFill xmlns:a="http://schemas.openxmlformats.org/drawingml/2006/main">
-            <a:schemeClr val="accent1">
-              <a:alpha val="16078"/>
-            </a:schemeClr>
-          </a:solidFill>
-          <a:ln xmlns:a="http://schemas.openxmlformats.org/drawingml/2006/main">
-            <a:noFill/>
-          </a:ln>
-        </p:spPr>
-        <p:style>
-          <a:lnRef xmlns:a="http://schemas.openxmlformats.org/drawingml/2006/main" idx="2">
-            <a:schemeClr val="accent1">
-              <a:lumMod val="75000"/>
-            </a:schemeClr>
-          </a:lnRef>
-          <a:fillRef xmlns:a="http://schemas.openxmlformats.org/drawingml/2006/main" idx="1">
-            <a:schemeClr val="accent1"/>
-          </a:fillRef>
-          <a:effectRef xmlns:a="http://schemas.openxmlformats.org/drawingml/2006/main" idx="0">
-            <a:srgbClr val="FFFFFF"/>
-          </a:effectRef>
-          <a:fontRef xmlns:a="http://schemas.openxmlformats.org/drawingml/2006/main" idx="minor">
-            <a:schemeClr val="lt1"/>
-          </a:fontRef>
-        </p:style>
-        <p:txBody>
-          <a:bodyPr xmlns:a="http://schemas.openxmlformats.org/drawingml/2006/main" anchor="ctr"/>
-          <a:lstStyle xmlns:a="http://schemas.openxmlformats.org/drawingml/2006/main"/>
-          <a:p xmlns:a="http://schemas.openxmlformats.org/drawingml/2006/main">
-            <a:pPr algn="ctr">
-              <a:buNone/>
-            </a:pPr>
-            <a:endParaRPr/>
-          </a:p>
-        </p:txBody>
-      </p:sp>
-      <p:sp>
-        <p:nvSpPr>
-          <p:cNvPr id="7" name="文本框 6">
-            <a:extLst xmlns:a="http://schemas.openxmlformats.org/drawingml/2006/main">
-              <a:ext uri="{FF2B5EF4-FFF2-40B4-BE49-F238E27FC236}">
-                <a16:creationId xmlns:a16="http://schemas.microsoft.com/office/drawing/2014/main" id="{86845DFB-C29D-4793-8ADA-F44D2C9B64B3}"/>
-              </a:ext>
-            </a:extLst>
-          </p:cNvPr>
-          <p:cNvSpPr>
-            <a:spLocks xmlns:a="http://schemas.openxmlformats.org/drawingml/2006/main" noGrp="1"/>
-          </p:cNvSpPr>
-          <p:nvPr/>
-        </p:nvSpPr>
-        <p:spPr>
-          <a:xfrm xmlns:a="http://schemas.openxmlformats.org/drawingml/2006/main">
-            <a:off x="812159" y="1885626"/>
-            <a:ext cx="471116" cy="239078"/>
-          </a:xfrm>
-          <a:prstGeom xmlns:a="http://schemas.openxmlformats.org/drawingml/2006/main" prst="rect">
-            <a:avLst/>
-          </a:prstGeom>
-          <a:noFill xmlns:a="http://schemas.openxmlformats.org/drawingml/2006/main"/>
-        </p:spPr>
-        <p:txBody>
-          <a:bodyPr xmlns:a="http://schemas.openxmlformats.org/drawingml/2006/main" wrap="square" lIns="0" tIns="0" rIns="0" bIns="0" anchor="t">
-            <a:noAutofit/>
-          </a:bodyPr>
-          <a:lstStyle xmlns:a="http://schemas.openxmlformats.org/drawingml/2006/main"/>
-          <a:p xmlns:a="http://schemas.openxmlformats.org/drawingml/2006/main">
-            <a:pPr algn="l">
-              <a:lnSpc>
-                <a:spcPct val="83000"/>
-              </a:lnSpc>
-              <a:buNone/>
-            </a:pPr>
-            <a:r>
-              <a:rPr sz="1650" b="1">
-                <a:solidFill>
-                  <a:srgbClr val="AF753D"/>
-                </a:solidFill>
-                <a:latin typeface="Microsoft YaHei"/>
-                <a:ea typeface="Microsoft YaHei"/>
-                <a:cs typeface="Microsoft YaHei"/>
-              </a:rPr>
-              <a:t>01</a:t>
-            </a:r>
-            <a:endParaRPr sz="1650" b="1">
-              <a:solidFill>
-                <a:srgbClr val="AF753D"/>
-              </a:solidFill>
-              <a:latin typeface="Microsoft YaHei"/>
-              <a:ea typeface="Microsoft YaHei"/>
-              <a:cs typeface="Microsoft YaHei"/>
-            </a:endParaRPr>
-          </a:p>
-        </p:txBody>
-      </p:sp>
-      <p:sp>
-        <p:nvSpPr>
-          <p:cNvPr id="8" name="文本框 7">
-            <a:extLst xmlns:a="http://schemas.openxmlformats.org/drawingml/2006/main">
-              <a:ext uri="{FF2B5EF4-FFF2-40B4-BE49-F238E27FC236}">
-                <a16:creationId xmlns:a16="http://schemas.microsoft.com/office/drawing/2014/main" id="{B3D7A74C-28DD-4B8C-AA13-7ED13F3C299F}"/>
-              </a:ext>
-            </a:extLst>
-          </p:cNvPr>
-          <p:cNvSpPr>
-            <a:spLocks xmlns:a="http://schemas.openxmlformats.org/drawingml/2006/main" noGrp="1"/>
-          </p:cNvSpPr>
-          <p:nvPr/>
-        </p:nvSpPr>
-        <p:spPr>
-          <a:xfrm xmlns:a="http://schemas.openxmlformats.org/drawingml/2006/main">
-            <a:off x="1228725" y="1874196"/>
-            <a:ext cx="2286000" cy="261938"/>
-          </a:xfrm>
-          <a:prstGeom xmlns:a="http://schemas.openxmlformats.org/drawingml/2006/main" prst="rect">
-            <a:avLst/>
-          </a:prstGeom>
-          <a:noFill xmlns:a="http://schemas.openxmlformats.org/drawingml/2006/main"/>
-        </p:spPr>
-        <p:txBody>
-          <a:bodyPr xmlns:a="http://schemas.openxmlformats.org/drawingml/2006/main" wrap="square" lIns="0" tIns="0" rIns="0" bIns="0" anchor="t">
-            <a:noAutofit/>
-          </a:bodyPr>
-          <a:lstStyle xmlns:a="http://schemas.openxmlformats.org/drawingml/2006/main"/>
-          <a:p xmlns:a="http://schemas.openxmlformats.org/drawingml/2006/main">
-            <a:pPr algn="l">
-              <a:lnSpc>
-                <a:spcPct val="104000"/>
-              </a:lnSpc>
-              <a:buNone/>
-            </a:pPr>
-            <a:r>
-              <a:rPr sz="1500" b="1">
-                <a:solidFill>
-                  <a:schemeClr val="tx2">
-                    <a:lumMod val="4356"/>
-                    <a:lumOff val="95644"/>
-                  </a:schemeClr>
-                </a:solidFill>
-                <a:latin typeface="Microsoft YaHei"/>
-                <a:ea typeface="Microsoft YaHei"/>
-                <a:cs typeface="Microsoft YaHei"/>
-              </a:rPr>
-              <a:t>只有图片，没有商品名</a:t>
-            </a:r>
-            <a:endParaRPr sz="1500" b="1">
-              <a:solidFill>
-                <a:schemeClr val="tx2">
-                  <a:lumMod val="4356"/>
-                  <a:lumOff val="95644"/>
-                </a:schemeClr>
-              </a:solidFill>
-              <a:latin typeface="Microsoft YaHei"/>
-              <a:ea typeface="Microsoft YaHei"/>
-              <a:cs typeface="Microsoft YaHei"/>
-            </a:endParaRPr>
-          </a:p>
-        </p:txBody>
-      </p:sp>
-      <p:sp>
-        <p:nvSpPr>
-          <p:cNvPr id="9" name="任意多边形 8">
-            <a:extLst xmlns:a="http://schemas.openxmlformats.org/drawingml/2006/main">
-              <a:ext uri="{FF2B5EF4-FFF2-40B4-BE49-F238E27FC236}">
-                <a16:creationId xmlns:a16="http://schemas.microsoft.com/office/drawing/2014/main" id="{A6630C45-5327-470B-B281-F5383522DFDE}"/>
-              </a:ext>
-            </a:extLst>
-          </p:cNvPr>
-          <p:cNvSpPr>
-            <a:spLocks xmlns:a="http://schemas.openxmlformats.org/drawingml/2006/main" noGrp="1"/>
-          </p:cNvSpPr>
-          <p:nvPr/>
-        </p:nvSpPr>
-        <p:spPr>
-          <a:xfrm xmlns:a="http://schemas.openxmlformats.org/drawingml/2006/main">
-            <a:off x="771525" y="2376170"/>
-            <a:ext cx="342900" cy="342900"/>
-          </a:xfrm>
-          <a:custGeom xmlns:a="http://schemas.openxmlformats.org/drawingml/2006/main">
-            <a:gdLst>
-              <a:gd name="sw" fmla="*/ 1 w 540"/>
-              <a:gd name="sh" fmla="*/ 1 h 540"/>
-              <a:gd name="mins" fmla="min sw sh"/>
-              <a:gd name="dsw" fmla="+- 0 sw mins"/>
-              <a:gd name="dsh" fmla="+- 0 sh mins"/>
-              <a:gd name="p0x0" fmla="*/ 120 w 540"/>
-              <a:gd name="p0y0" fmla="*/ 0 h 540"/>
-              <a:gd name="p0x1" fmla="*/ 420 w 540"/>
-              <a:gd name="p0y1" fmla="*/ 0 h 540"/>
-              <a:gd name="p0x2" fmla="*/ 486 w 540"/>
-              <a:gd name="p0y2" fmla="*/ 0 h 540"/>
-              <a:gd name="p0x3" fmla="*/ 540 w 540"/>
-              <a:gd name="p0y3" fmla="*/ 53 h 540"/>
-              <a:gd name="p0x4" fmla="*/ 540 w 540"/>
-              <a:gd name="p0y4" fmla="*/ 120 h 540"/>
-              <a:gd name="p0x5" fmla="*/ 540 w 540"/>
-              <a:gd name="p0y5" fmla="*/ 420 h 540"/>
-              <a:gd name="p0x6" fmla="*/ 540 w 540"/>
-              <a:gd name="p0y6" fmla="*/ 486 h 540"/>
-              <a:gd name="p0x7" fmla="*/ 486 w 540"/>
-              <a:gd name="p0y7" fmla="*/ 540 h 540"/>
-              <a:gd name="p0x8" fmla="*/ 420 w 540"/>
-              <a:gd name="p0y8" fmla="*/ 540 h 540"/>
-              <a:gd name="p0x9" fmla="*/ 120 w 540"/>
-              <a:gd name="p0y9" fmla="*/ 540 h 540"/>
-              <a:gd name="p0x10" fmla="*/ 53 w 540"/>
-              <a:gd name="p0y10" fmla="*/ 540 h 540"/>
-              <a:gd name="p0x11" fmla="*/ 0 w 540"/>
-              <a:gd name="p0y11" fmla="*/ 486 h 540"/>
-              <a:gd name="p0x12" fmla="*/ 0 w 540"/>
-              <a:gd name="p0y12" fmla="*/ 420 h 540"/>
-              <a:gd name="p0x13" fmla="*/ 0 w 540"/>
-              <a:gd name="p0y13" fmla="*/ 120 h 540"/>
-              <a:gd name="p0x14" fmla="*/ 0 w 540"/>
-              <a:gd name="p0y14" fmla="*/ 53 h 540"/>
-              <a:gd name="p0x15" fmla="*/ 53 w 540"/>
-              <a:gd name="p0y15" fmla="*/ 0 h 540"/>
-              <a:gd name="p0x16" fmla="*/ 120 w 540"/>
-              <a:gd name="p0y16" fmla="*/ 0 h 540"/>
-            </a:gdLst>
-            <a:pathLst>
-              <a:path w="0" h="0">
-                <a:moveTo>
-                  <a:pt x="0" y="0"/>
-                </a:moveTo>
-                <a:lnTo>
-                  <a:pt x="0" y="0"/>
-                </a:lnTo>
-                <a:cubicBezTo>
-                  <a:pt x="0" y="0"/>
-                  <a:pt x="0" y="0"/>
-                  <a:pt x="0" y="0"/>
-                </a:cubicBezTo>
-                <a:lnTo>
-                  <a:pt x="0" y="0"/>
-                </a:lnTo>
-                <a:cubicBezTo>
-                  <a:pt x="0" y="0"/>
-                  <a:pt x="0" y="0"/>
-                  <a:pt x="0" y="0"/>
-                </a:cubicBezTo>
-                <a:lnTo>
-                  <a:pt x="0" y="0"/>
-                </a:lnTo>
-                <a:cubicBezTo>
-                  <a:pt x="0" y="0"/>
-                  <a:pt x="0" y="0"/>
-                  <a:pt x="0" y="0"/>
-                </a:cubicBezTo>
-                <a:lnTo>
-                  <a:pt x="0" y="0"/>
-                </a:lnTo>
-                <a:cubicBezTo>
-                  <a:pt x="0" y="0"/>
-                  <a:pt x="0" y="0"/>
-                  <a:pt x="0" y="0"/>
-                </a:cubicBezTo>
-                <a:close/>
-              </a:path>
-            </a:pathLst>
-          </a:custGeom>
-          <a:solidFill xmlns:a="http://schemas.openxmlformats.org/drawingml/2006/main">
-            <a:schemeClr val="accent1">
-              <a:alpha val="16078"/>
-            </a:schemeClr>
-          </a:solidFill>
-          <a:ln xmlns:a="http://schemas.openxmlformats.org/drawingml/2006/main">
-            <a:noFill/>
-          </a:ln>
-        </p:spPr>
-        <p:style>
-          <a:lnRef xmlns:a="http://schemas.openxmlformats.org/drawingml/2006/main" idx="2">
-            <a:schemeClr val="accent1">
-              <a:lumMod val="75000"/>
-            </a:schemeClr>
-          </a:lnRef>
-          <a:fillRef xmlns:a="http://schemas.openxmlformats.org/drawingml/2006/main" idx="1">
-            <a:schemeClr val="accent1"/>
-          </a:fillRef>
-          <a:effectRef xmlns:a="http://schemas.openxmlformats.org/drawingml/2006/main" idx="0">
-            <a:srgbClr val="FFFFFF"/>
-          </a:effectRef>
-          <a:fontRef xmlns:a="http://schemas.openxmlformats.org/drawingml/2006/main" idx="minor">
-            <a:schemeClr val="lt1"/>
-          </a:fontRef>
-        </p:style>
-        <p:txBody>
-          <a:bodyPr xmlns:a="http://schemas.openxmlformats.org/drawingml/2006/main" anchor="ctr"/>
-          <a:lstStyle xmlns:a="http://schemas.openxmlformats.org/drawingml/2006/main"/>
-          <a:p xmlns:a="http://schemas.openxmlformats.org/drawingml/2006/main">
-            <a:pPr algn="ctr">
-              <a:buNone/>
-            </a:pPr>
-            <a:endParaRPr/>
-          </a:p>
-        </p:txBody>
-      </p:sp>
-      <p:sp>
-        <p:nvSpPr>
-          <p:cNvPr id="10" name="文本框 9">
-            <a:extLst xmlns:a="http://schemas.openxmlformats.org/drawingml/2006/main">
-              <a:ext uri="{FF2B5EF4-FFF2-40B4-BE49-F238E27FC236}">
-                <a16:creationId xmlns:a16="http://schemas.microsoft.com/office/drawing/2014/main" id="{963561B0-ED28-494D-8C9F-3EEA93C42813}"/>
-              </a:ext>
-            </a:extLst>
-          </p:cNvPr>
-          <p:cNvSpPr>
-            <a:spLocks xmlns:a="http://schemas.openxmlformats.org/drawingml/2006/main" noGrp="1"/>
-          </p:cNvSpPr>
-          <p:nvPr/>
-        </p:nvSpPr>
-        <p:spPr>
-          <a:xfrm xmlns:a="http://schemas.openxmlformats.org/drawingml/2006/main">
-            <a:off x="812159" y="2426313"/>
-            <a:ext cx="471116" cy="239078"/>
-          </a:xfrm>
-          <a:prstGeom xmlns:a="http://schemas.openxmlformats.org/drawingml/2006/main" prst="rect">
-            <a:avLst/>
-          </a:prstGeom>
-          <a:noFill xmlns:a="http://schemas.openxmlformats.org/drawingml/2006/main"/>
-        </p:spPr>
-        <p:txBody>
-          <a:bodyPr xmlns:a="http://schemas.openxmlformats.org/drawingml/2006/main" wrap="square" lIns="0" tIns="0" rIns="0" bIns="0" anchor="t">
-            <a:noAutofit/>
-          </a:bodyPr>
-          <a:lstStyle xmlns:a="http://schemas.openxmlformats.org/drawingml/2006/main"/>
-          <a:p xmlns:a="http://schemas.openxmlformats.org/drawingml/2006/main">
-            <a:pPr algn="l">
-              <a:lnSpc>
-                <a:spcPct val="83000"/>
-              </a:lnSpc>
-              <a:buNone/>
-            </a:pPr>
-            <a:r>
-              <a:rPr sz="1650" b="1">
-                <a:solidFill>
-                  <a:srgbClr val="AF753D"/>
-                </a:solidFill>
-                <a:latin typeface="Microsoft YaHei"/>
-                <a:ea typeface="Microsoft YaHei"/>
-                <a:cs typeface="Microsoft YaHei"/>
-              </a:rPr>
-              <a:t>02</a:t>
-            </a:r>
-            <a:endParaRPr sz="1650" b="1">
-              <a:solidFill>
-                <a:srgbClr val="AF753D"/>
-              </a:solidFill>
-              <a:latin typeface="Microsoft YaHei"/>
-              <a:ea typeface="Microsoft YaHei"/>
-              <a:cs typeface="Microsoft YaHei"/>
-            </a:endParaRPr>
-          </a:p>
-        </p:txBody>
-      </p:sp>
-      <p:sp>
-        <p:nvSpPr>
-          <p:cNvPr id="11" name="文本框 10">
-            <a:extLst xmlns:a="http://schemas.openxmlformats.org/drawingml/2006/main">
-              <a:ext uri="{FF2B5EF4-FFF2-40B4-BE49-F238E27FC236}">
-                <a16:creationId xmlns:a16="http://schemas.microsoft.com/office/drawing/2014/main" id="{1E84E92B-EBA6-4E57-80D9-DAA326EAF761}"/>
-              </a:ext>
-            </a:extLst>
-          </p:cNvPr>
-          <p:cNvSpPr>
-            <a:spLocks xmlns:a="http://schemas.openxmlformats.org/drawingml/2006/main" noGrp="1"/>
-          </p:cNvSpPr>
-          <p:nvPr/>
-        </p:nvSpPr>
-        <p:spPr>
-          <a:xfrm xmlns:a="http://schemas.openxmlformats.org/drawingml/2006/main">
-            <a:off x="1228725" y="2414883"/>
-            <a:ext cx="3619500" cy="261938"/>
-          </a:xfrm>
-          <a:prstGeom xmlns:a="http://schemas.openxmlformats.org/drawingml/2006/main" prst="rect">
-            <a:avLst/>
-          </a:prstGeom>
-          <a:noFill xmlns:a="http://schemas.openxmlformats.org/drawingml/2006/main"/>
-        </p:spPr>
-        <p:txBody>
-          <a:bodyPr xmlns:a="http://schemas.openxmlformats.org/drawingml/2006/main" wrap="square" lIns="0" tIns="0" rIns="0" bIns="0" anchor="t">
-            <a:noAutofit/>
-          </a:bodyPr>
-          <a:lstStyle xmlns:a="http://schemas.openxmlformats.org/drawingml/2006/main"/>
-          <a:p xmlns:a="http://schemas.openxmlformats.org/drawingml/2006/main">
-            <a:pPr algn="l">
-              <a:lnSpc>
-                <a:spcPct val="104000"/>
-              </a:lnSpc>
-              <a:buNone/>
-            </a:pPr>
-            <a:r>
-              <a:rPr sz="1500" b="1">
-                <a:solidFill>
-                  <a:schemeClr val="tx2">
-                    <a:lumMod val="4356"/>
-                    <a:lumOff val="95644"/>
-                  </a:schemeClr>
-                </a:solidFill>
-                <a:latin typeface="Microsoft YaHei"/>
-                <a:ea typeface="Microsoft YaHei"/>
-                <a:cs typeface="Microsoft YaHei"/>
-              </a:rPr>
-              <a:t>缺少品牌、型号、规格等检索词</a:t>
-            </a:r>
-            <a:endParaRPr sz="1500" b="1">
-              <a:solidFill>
-                <a:schemeClr val="tx2">
-                  <a:lumMod val="4356"/>
-                  <a:lumOff val="95644"/>
-                </a:schemeClr>
-              </a:solidFill>
-              <a:latin typeface="Microsoft YaHei"/>
-              <a:ea typeface="Microsoft YaHei"/>
-              <a:cs typeface="Microsoft YaHei"/>
-            </a:endParaRPr>
-          </a:p>
-        </p:txBody>
-      </p:sp>
-      <p:sp>
-        <p:nvSpPr>
-          <p:cNvPr id="12" name="任意多边形 11">
-            <a:extLst xmlns:a="http://schemas.openxmlformats.org/drawingml/2006/main">
-              <a:ext uri="{FF2B5EF4-FFF2-40B4-BE49-F238E27FC236}">
-                <a16:creationId xmlns:a16="http://schemas.microsoft.com/office/drawing/2014/main" id="{5DA6AA57-C9D3-4AB1-ACE8-F3110486FEA2}"/>
-              </a:ext>
-            </a:extLst>
-          </p:cNvPr>
-          <p:cNvSpPr>
-            <a:spLocks xmlns:a="http://schemas.openxmlformats.org/drawingml/2006/main" noGrp="1"/>
-          </p:cNvSpPr>
-          <p:nvPr/>
-        </p:nvSpPr>
-        <p:spPr>
-          <a:xfrm xmlns:a="http://schemas.openxmlformats.org/drawingml/2006/main">
-            <a:off x="771525" y="2917190"/>
-            <a:ext cx="342900" cy="342900"/>
-          </a:xfrm>
-          <a:custGeom xmlns:a="http://schemas.openxmlformats.org/drawingml/2006/main">
-            <a:gdLst>
-              <a:gd name="sw" fmla="*/ 1 w 540"/>
-              <a:gd name="sh" fmla="*/ 1 h 540"/>
-              <a:gd name="mins" fmla="min sw sh"/>
-              <a:gd name="dsw" fmla="+- 0 sw mins"/>
-              <a:gd name="dsh" fmla="+- 0 sh mins"/>
-              <a:gd name="p0x0" fmla="*/ 120 w 540"/>
-              <a:gd name="p0y0" fmla="*/ 0 h 540"/>
-              <a:gd name="p0x1" fmla="*/ 420 w 540"/>
-              <a:gd name="p0y1" fmla="*/ 0 h 540"/>
-              <a:gd name="p0x2" fmla="*/ 486 w 540"/>
-              <a:gd name="p0y2" fmla="*/ 0 h 540"/>
-              <a:gd name="p0x3" fmla="*/ 540 w 540"/>
-              <a:gd name="p0y3" fmla="*/ 53 h 540"/>
-              <a:gd name="p0x4" fmla="*/ 540 w 540"/>
-              <a:gd name="p0y4" fmla="*/ 120 h 540"/>
-              <a:gd name="p0x5" fmla="*/ 540 w 540"/>
-              <a:gd name="p0y5" fmla="*/ 420 h 540"/>
-              <a:gd name="p0x6" fmla="*/ 540 w 540"/>
-              <a:gd name="p0y6" fmla="*/ 486 h 540"/>
-              <a:gd name="p0x7" fmla="*/ 486 w 540"/>
-              <a:gd name="p0y7" fmla="*/ 540 h 540"/>
-              <a:gd name="p0x8" fmla="*/ 420 w 540"/>
-              <a:gd name="p0y8" fmla="*/ 540 h 540"/>
-              <a:gd name="p0x9" fmla="*/ 120 w 540"/>
-              <a:gd name="p0y9" fmla="*/ 540 h 540"/>
-              <a:gd name="p0x10" fmla="*/ 53 w 540"/>
-              <a:gd name="p0y10" fmla="*/ 540 h 540"/>
-              <a:gd name="p0x11" fmla="*/ 0 w 540"/>
-              <a:gd name="p0y11" fmla="*/ 486 h 540"/>
-              <a:gd name="p0x12" fmla="*/ 0 w 540"/>
-              <a:gd name="p0y12" fmla="*/ 420 h 540"/>
-              <a:gd name="p0x13" fmla="*/ 0 w 540"/>
-              <a:gd name="p0y13" fmla="*/ 120 h 540"/>
-              <a:gd name="p0x14" fmla="*/ 0 w 540"/>
-              <a:gd name="p0y14" fmla="*/ 53 h 540"/>
-              <a:gd name="p0x15" fmla="*/ 53 w 540"/>
-              <a:gd name="p0y15" fmla="*/ 0 h 540"/>
-              <a:gd name="p0x16" fmla="*/ 120 w 540"/>
-              <a:gd name="p0y16" fmla="*/ 0 h 540"/>
-            </a:gdLst>
-            <a:pathLst>
-              <a:path w="0" h="0">
-                <a:moveTo>
-                  <a:pt x="0" y="0"/>
-                </a:moveTo>
-                <a:lnTo>
-                  <a:pt x="0" y="0"/>
-                </a:lnTo>
-                <a:cubicBezTo>
-                  <a:pt x="0" y="0"/>
-                  <a:pt x="0" y="0"/>
-                  <a:pt x="0" y="0"/>
-                </a:cubicBezTo>
-                <a:lnTo>
-                  <a:pt x="0" y="0"/>
-                </a:lnTo>
-                <a:cubicBezTo>
-                  <a:pt x="0" y="0"/>
-                  <a:pt x="0" y="0"/>
-                  <a:pt x="0" y="0"/>
-                </a:cubicBezTo>
-                <a:lnTo>
-                  <a:pt x="0" y="0"/>
-                </a:lnTo>
-                <a:cubicBezTo>
-                  <a:pt x="0" y="0"/>
-                  <a:pt x="0" y="0"/>
-                  <a:pt x="0" y="0"/>
-                </a:cubicBezTo>
-                <a:lnTo>
-                  <a:pt x="0" y="0"/>
-                </a:lnTo>
-                <a:cubicBezTo>
-                  <a:pt x="0" y="0"/>
-                  <a:pt x="0" y="0"/>
-                  <a:pt x="0" y="0"/>
-                </a:cubicBezTo>
-                <a:close/>
-              </a:path>
-            </a:pathLst>
-          </a:custGeom>
-          <a:solidFill xmlns:a="http://schemas.openxmlformats.org/drawingml/2006/main">
-            <a:schemeClr val="accent1">
-              <a:alpha val="16078"/>
-            </a:schemeClr>
-          </a:solidFill>
-          <a:ln xmlns:a="http://schemas.openxmlformats.org/drawingml/2006/main">
-            <a:noFill/>
-          </a:ln>
-        </p:spPr>
-        <p:style>
-          <a:lnRef xmlns:a="http://schemas.openxmlformats.org/drawingml/2006/main" idx="2">
-            <a:schemeClr val="accent1">
-              <a:lumMod val="75000"/>
-            </a:schemeClr>
-          </a:lnRef>
-          <a:fillRef xmlns:a="http://schemas.openxmlformats.org/drawingml/2006/main" idx="1">
-            <a:schemeClr val="accent1"/>
-          </a:fillRef>
-          <a:effectRef xmlns:a="http://schemas.openxmlformats.org/drawingml/2006/main" idx="0">
-            <a:srgbClr val="FFFFFF"/>
-          </a:effectRef>
-          <a:fontRef xmlns:a="http://schemas.openxmlformats.org/drawingml/2006/main" idx="minor">
-            <a:schemeClr val="lt1"/>
-          </a:fontRef>
-        </p:style>
-        <p:txBody>
-          <a:bodyPr xmlns:a="http://schemas.openxmlformats.org/drawingml/2006/main" anchor="ctr"/>
-          <a:lstStyle xmlns:a="http://schemas.openxmlformats.org/drawingml/2006/main"/>
-          <a:p xmlns:a="http://schemas.openxmlformats.org/drawingml/2006/main">
-            <a:pPr algn="ctr">
-              <a:buNone/>
-            </a:pPr>
-            <a:endParaRPr/>
-          </a:p>
-        </p:txBody>
-      </p:sp>
-      <p:sp>
-        <p:nvSpPr>
-          <p:cNvPr id="13" name="文本框 12">
-            <a:extLst xmlns:a="http://schemas.openxmlformats.org/drawingml/2006/main">
-              <a:ext uri="{FF2B5EF4-FFF2-40B4-BE49-F238E27FC236}">
-                <a16:creationId xmlns:a16="http://schemas.microsoft.com/office/drawing/2014/main" id="{21568BDD-9B54-4DBE-A923-C8BA6A0FB8D2}"/>
-              </a:ext>
-            </a:extLst>
-          </p:cNvPr>
-          <p:cNvSpPr>
-            <a:spLocks xmlns:a="http://schemas.openxmlformats.org/drawingml/2006/main" noGrp="1"/>
-          </p:cNvSpPr>
-          <p:nvPr/>
-        </p:nvSpPr>
-        <p:spPr>
-          <a:xfrm xmlns:a="http://schemas.openxmlformats.org/drawingml/2006/main">
-            <a:off x="812159" y="2967009"/>
-            <a:ext cx="471116" cy="239078"/>
-          </a:xfrm>
-          <a:prstGeom xmlns:a="http://schemas.openxmlformats.org/drawingml/2006/main" prst="rect">
-            <a:avLst/>
-          </a:prstGeom>
-          <a:noFill xmlns:a="http://schemas.openxmlformats.org/drawingml/2006/main"/>
-        </p:spPr>
-        <p:txBody>
-          <a:bodyPr xmlns:a="http://schemas.openxmlformats.org/drawingml/2006/main" wrap="square" lIns="0" tIns="0" rIns="0" bIns="0" anchor="t">
-            <a:noAutofit/>
-          </a:bodyPr>
-          <a:lstStyle xmlns:a="http://schemas.openxmlformats.org/drawingml/2006/main"/>
-          <a:p xmlns:a="http://schemas.openxmlformats.org/drawingml/2006/main">
-            <a:pPr algn="l">
-              <a:lnSpc>
-                <a:spcPct val="83000"/>
-              </a:lnSpc>
-              <a:buNone/>
-            </a:pPr>
-            <a:r>
-              <a:rPr sz="1650" b="1">
-                <a:solidFill>
-                  <a:srgbClr val="AF753D"/>
-                </a:solidFill>
-                <a:latin typeface="Microsoft YaHei"/>
-                <a:ea typeface="Microsoft YaHei"/>
-                <a:cs typeface="Microsoft YaHei"/>
-              </a:rPr>
-              <a:t>03</a:t>
-            </a:r>
-            <a:endParaRPr sz="1650" b="1">
-              <a:solidFill>
-                <a:srgbClr val="AF753D"/>
-              </a:solidFill>
-              <a:latin typeface="Microsoft YaHei"/>
-              <a:ea typeface="Microsoft YaHei"/>
-              <a:cs typeface="Microsoft YaHei"/>
-            </a:endParaRPr>
-          </a:p>
-        </p:txBody>
-      </p:sp>
-      <p:sp>
-        <p:nvSpPr>
-          <p:cNvPr id="14" name="文本框 13">
-            <a:extLst xmlns:a="http://schemas.openxmlformats.org/drawingml/2006/main">
-              <a:ext uri="{FF2B5EF4-FFF2-40B4-BE49-F238E27FC236}">
-                <a16:creationId xmlns:a16="http://schemas.microsoft.com/office/drawing/2014/main" id="{BF519AB1-A2E3-4944-9D7E-F7145AED02FE}"/>
-              </a:ext>
-            </a:extLst>
-          </p:cNvPr>
-          <p:cNvSpPr>
-            <a:spLocks xmlns:a="http://schemas.openxmlformats.org/drawingml/2006/main" noGrp="1"/>
-          </p:cNvSpPr>
-          <p:nvPr/>
-        </p:nvSpPr>
-        <p:spPr>
-          <a:xfrm xmlns:a="http://schemas.openxmlformats.org/drawingml/2006/main">
-            <a:off x="1228725" y="2955579"/>
-            <a:ext cx="2667000" cy="261938"/>
-          </a:xfrm>
-          <a:prstGeom xmlns:a="http://schemas.openxmlformats.org/drawingml/2006/main" prst="rect">
-            <a:avLst/>
-          </a:prstGeom>
-          <a:noFill xmlns:a="http://schemas.openxmlformats.org/drawingml/2006/main"/>
-        </p:spPr>
-        <p:txBody>
-          <a:bodyPr xmlns:a="http://schemas.openxmlformats.org/drawingml/2006/main" wrap="square" lIns="0" tIns="0" rIns="0" bIns="0" anchor="t">
-            <a:noAutofit/>
-          </a:bodyPr>
-          <a:lstStyle xmlns:a="http://schemas.openxmlformats.org/drawingml/2006/main"/>
-          <a:p xmlns:a="http://schemas.openxmlformats.org/drawingml/2006/main">
-            <a:pPr algn="l">
-              <a:lnSpc>
-                <a:spcPct val="104000"/>
-              </a:lnSpc>
-              <a:buNone/>
-            </a:pPr>
-            <a:r>
-              <a:rPr sz="1500" b="1">
-                <a:solidFill>
-                  <a:schemeClr val="tx2">
-                    <a:lumMod val="4356"/>
-                    <a:lumOff val="95644"/>
-                  </a:schemeClr>
-                </a:solidFill>
-                <a:latin typeface="Microsoft YaHei"/>
-                <a:ea typeface="Microsoft YaHei"/>
-                <a:cs typeface="Microsoft YaHei"/>
-              </a:rPr>
-              <a:t>相似外观不能证明同款</a:t>
-            </a:r>
-            <a:endParaRPr sz="1500" b="1">
-              <a:solidFill>
-                <a:schemeClr val="tx2">
-                  <a:lumMod val="4356"/>
-                  <a:lumOff val="95644"/>
-                </a:schemeClr>
-              </a:solidFill>
-              <a:latin typeface="Microsoft YaHei"/>
-              <a:ea typeface="Microsoft YaHei"/>
-              <a:cs typeface="Microsoft YaHei"/>
-            </a:endParaRPr>
-          </a:p>
-        </p:txBody>
-      </p:sp>
-      <p:sp>
-        <p:nvSpPr>
-          <p:cNvPr id="15" name="任意多边形 14">
-            <a:extLst xmlns:a="http://schemas.openxmlformats.org/drawingml/2006/main">
-              <a:ext uri="{FF2B5EF4-FFF2-40B4-BE49-F238E27FC236}">
-                <a16:creationId xmlns:a16="http://schemas.microsoft.com/office/drawing/2014/main" id="{0D7EEADE-68C9-4078-8746-55C131365D44}"/>
-              </a:ext>
-            </a:extLst>
-          </p:cNvPr>
-          <p:cNvSpPr>
-            <a:spLocks xmlns:a="http://schemas.openxmlformats.org/drawingml/2006/main" noGrp="1"/>
-          </p:cNvSpPr>
-          <p:nvPr/>
-        </p:nvSpPr>
-        <p:spPr>
-          <a:xfrm xmlns:a="http://schemas.openxmlformats.org/drawingml/2006/main">
-            <a:off x="771525" y="3457575"/>
-            <a:ext cx="342900" cy="342900"/>
-          </a:xfrm>
-          <a:custGeom xmlns:a="http://schemas.openxmlformats.org/drawingml/2006/main">
-            <a:gdLst>
-              <a:gd name="sw" fmla="*/ 1 w 540"/>
-              <a:gd name="sh" fmla="*/ 1 h 540"/>
-              <a:gd name="mins" fmla="min sw sh"/>
-              <a:gd name="dsw" fmla="+- 0 sw mins"/>
-              <a:gd name="dsh" fmla="+- 0 sh mins"/>
-              <a:gd name="p0x0" fmla="*/ 120 w 540"/>
-              <a:gd name="p0y0" fmla="*/ 0 h 540"/>
-              <a:gd name="p0x1" fmla="*/ 420 w 540"/>
-              <a:gd name="p0y1" fmla="*/ 0 h 540"/>
-              <a:gd name="p0x2" fmla="*/ 486 w 540"/>
-              <a:gd name="p0y2" fmla="*/ 0 h 540"/>
-              <a:gd name="p0x3" fmla="*/ 540 w 540"/>
-              <a:gd name="p0y3" fmla="*/ 53 h 540"/>
-              <a:gd name="p0x4" fmla="*/ 540 w 540"/>
-              <a:gd name="p0y4" fmla="*/ 120 h 540"/>
-              <a:gd name="p0x5" fmla="*/ 540 w 540"/>
-              <a:gd name="p0y5" fmla="*/ 420 h 540"/>
-              <a:gd name="p0x6" fmla="*/ 540 w 540"/>
-              <a:gd name="p0y6" fmla="*/ 486 h 540"/>
-              <a:gd name="p0x7" fmla="*/ 486 w 540"/>
-              <a:gd name="p0y7" fmla="*/ 540 h 540"/>
-              <a:gd name="p0x8" fmla="*/ 420 w 540"/>
-              <a:gd name="p0y8" fmla="*/ 540 h 540"/>
-              <a:gd name="p0x9" fmla="*/ 120 w 540"/>
-              <a:gd name="p0y9" fmla="*/ 540 h 540"/>
-              <a:gd name="p0x10" fmla="*/ 53 w 540"/>
-              <a:gd name="p0y10" fmla="*/ 540 h 540"/>
-              <a:gd name="p0x11" fmla="*/ 0 w 540"/>
-              <a:gd name="p0y11" fmla="*/ 486 h 540"/>
-              <a:gd name="p0x12" fmla="*/ 0 w 540"/>
-              <a:gd name="p0y12" fmla="*/ 420 h 540"/>
-              <a:gd name="p0x13" fmla="*/ 0 w 540"/>
-              <a:gd name="p0y13" fmla="*/ 120 h 540"/>
-              <a:gd name="p0x14" fmla="*/ 0 w 540"/>
-              <a:gd name="p0y14" fmla="*/ 53 h 540"/>
-              <a:gd name="p0x15" fmla="*/ 53 w 540"/>
-              <a:gd name="p0y15" fmla="*/ 0 h 540"/>
-              <a:gd name="p0x16" fmla="*/ 120 w 540"/>
-              <a:gd name="p0y16" fmla="*/ 0 h 540"/>
-            </a:gdLst>
-            <a:pathLst>
-              <a:path w="0" h="0">
-                <a:moveTo>
-                  <a:pt x="0" y="0"/>
-                </a:moveTo>
-                <a:lnTo>
-                  <a:pt x="0" y="0"/>
-                </a:lnTo>
-                <a:cubicBezTo>
-                  <a:pt x="0" y="0"/>
-                  <a:pt x="0" y="0"/>
-                  <a:pt x="0" y="0"/>
-                </a:cubicBezTo>
-                <a:lnTo>
-                  <a:pt x="0" y="0"/>
-                </a:lnTo>
-                <a:cubicBezTo>
-                  <a:pt x="0" y="0"/>
-                  <a:pt x="0" y="0"/>
-                  <a:pt x="0" y="0"/>
-                </a:cubicBezTo>
-                <a:lnTo>
-                  <a:pt x="0" y="0"/>
-                </a:lnTo>
-                <a:cubicBezTo>
-                  <a:pt x="0" y="0"/>
-                  <a:pt x="0" y="0"/>
-                  <a:pt x="0" y="0"/>
-                </a:cubicBezTo>
-                <a:lnTo>
-                  <a:pt x="0" y="0"/>
-                </a:lnTo>
-                <a:cubicBezTo>
-                  <a:pt x="0" y="0"/>
-                  <a:pt x="0" y="0"/>
-                  <a:pt x="0" y="0"/>
-                </a:cubicBezTo>
-                <a:close/>
-              </a:path>
-            </a:pathLst>
-          </a:custGeom>
-          <a:solidFill xmlns:a="http://schemas.openxmlformats.org/drawingml/2006/main">
-            <a:schemeClr val="accent1">
-              <a:alpha val="16078"/>
-            </a:schemeClr>
-          </a:solidFill>
-          <a:ln xmlns:a="http://schemas.openxmlformats.org/drawingml/2006/main">
-            <a:noFill/>
-          </a:ln>
-        </p:spPr>
-        <p:style>
-          <a:lnRef xmlns:a="http://schemas.openxmlformats.org/drawingml/2006/main" idx="2">
-            <a:schemeClr val="accent1">
-              <a:lumMod val="75000"/>
-            </a:schemeClr>
-          </a:lnRef>
-          <a:fillRef xmlns:a="http://schemas.openxmlformats.org/drawingml/2006/main" idx="1">
-            <a:schemeClr val="accent1"/>
-          </a:fillRef>
-          <a:effectRef xmlns:a="http://schemas.openxmlformats.org/drawingml/2006/main" idx="0">
-            <a:srgbClr val="FFFFFF"/>
-          </a:effectRef>
-          <a:fontRef xmlns:a="http://schemas.openxmlformats.org/drawingml/2006/main" idx="minor">
-            <a:schemeClr val="lt1"/>
-          </a:fontRef>
-        </p:style>
-        <p:txBody>
-          <a:bodyPr xmlns:a="http://schemas.openxmlformats.org/drawingml/2006/main" anchor="ctr"/>
-          <a:lstStyle xmlns:a="http://schemas.openxmlformats.org/drawingml/2006/main"/>
-          <a:p xmlns:a="http://schemas.openxmlformats.org/drawingml/2006/main">
-            <a:pPr algn="ctr">
-              <a:buNone/>
-            </a:pPr>
-            <a:endParaRPr/>
-          </a:p>
-        </p:txBody>
-      </p:sp>
-      <p:sp>
-        <p:nvSpPr>
-          <p:cNvPr id="16" name="文本框 15">
-            <a:extLst xmlns:a="http://schemas.openxmlformats.org/drawingml/2006/main">
-              <a:ext uri="{FF2B5EF4-FFF2-40B4-BE49-F238E27FC236}">
-                <a16:creationId xmlns:a16="http://schemas.microsoft.com/office/drawing/2014/main" id="{C2FB8420-960F-4194-B059-8EA87F0F104F}"/>
-              </a:ext>
-            </a:extLst>
-          </p:cNvPr>
-          <p:cNvSpPr>
-            <a:spLocks xmlns:a="http://schemas.openxmlformats.org/drawingml/2006/main" noGrp="1"/>
-          </p:cNvSpPr>
-          <p:nvPr/>
-        </p:nvSpPr>
-        <p:spPr>
-          <a:xfrm xmlns:a="http://schemas.openxmlformats.org/drawingml/2006/main">
-            <a:off x="812159" y="3507705"/>
-            <a:ext cx="471116" cy="239078"/>
-          </a:xfrm>
-          <a:prstGeom xmlns:a="http://schemas.openxmlformats.org/drawingml/2006/main" prst="rect">
-            <a:avLst/>
-          </a:prstGeom>
-          <a:noFill xmlns:a="http://schemas.openxmlformats.org/drawingml/2006/main"/>
-        </p:spPr>
-        <p:txBody>
-          <a:bodyPr xmlns:a="http://schemas.openxmlformats.org/drawingml/2006/main" wrap="square" lIns="0" tIns="0" rIns="0" bIns="0" anchor="t">
-            <a:noAutofit/>
-          </a:bodyPr>
-          <a:lstStyle xmlns:a="http://schemas.openxmlformats.org/drawingml/2006/main"/>
-          <a:p xmlns:a="http://schemas.openxmlformats.org/drawingml/2006/main">
-            <a:pPr algn="l">
-              <a:lnSpc>
-                <a:spcPct val="83000"/>
-              </a:lnSpc>
-              <a:buNone/>
-            </a:pPr>
-            <a:r>
-              <a:rPr sz="1650" b="1">
-                <a:solidFill>
-                  <a:srgbClr val="AF753D"/>
-                </a:solidFill>
-                <a:latin typeface="Microsoft YaHei"/>
-                <a:ea typeface="Microsoft YaHei"/>
-                <a:cs typeface="Microsoft YaHei"/>
-              </a:rPr>
-              <a:t>04</a:t>
-            </a:r>
-            <a:endParaRPr sz="1650" b="1">
-              <a:solidFill>
-                <a:srgbClr val="AF753D"/>
-              </a:solidFill>
-              <a:latin typeface="Microsoft YaHei"/>
-              <a:ea typeface="Microsoft YaHei"/>
-              <a:cs typeface="Microsoft YaHei"/>
-            </a:endParaRPr>
-          </a:p>
-        </p:txBody>
-      </p:sp>
-      <p:sp>
-        <p:nvSpPr>
-          <p:cNvPr id="17" name="文本框 16">
-            <a:extLst xmlns:a="http://schemas.openxmlformats.org/drawingml/2006/main">
-              <a:ext uri="{FF2B5EF4-FFF2-40B4-BE49-F238E27FC236}">
-                <a16:creationId xmlns:a16="http://schemas.microsoft.com/office/drawing/2014/main" id="{76520457-C4BE-4CA2-91EF-8C5930A74156}"/>
-              </a:ext>
-            </a:extLst>
-          </p:cNvPr>
-          <p:cNvSpPr>
-            <a:spLocks xmlns:a="http://schemas.openxmlformats.org/drawingml/2006/main" noGrp="1"/>
-          </p:cNvSpPr>
-          <p:nvPr/>
-        </p:nvSpPr>
-        <p:spPr>
-          <a:xfrm xmlns:a="http://schemas.openxmlformats.org/drawingml/2006/main">
-            <a:off x="1228725" y="3496275"/>
-            <a:ext cx="4572000" cy="261938"/>
-          </a:xfrm>
-          <a:prstGeom xmlns:a="http://schemas.openxmlformats.org/drawingml/2006/main" prst="rect">
-            <a:avLst/>
-          </a:prstGeom>
-          <a:noFill xmlns:a="http://schemas.openxmlformats.org/drawingml/2006/main"/>
-        </p:spPr>
-        <p:txBody>
-          <a:bodyPr xmlns:a="http://schemas.openxmlformats.org/drawingml/2006/main" wrap="square" lIns="0" tIns="0" rIns="0" bIns="0" anchor="t">
-            <a:noAutofit/>
-          </a:bodyPr>
-          <a:lstStyle xmlns:a="http://schemas.openxmlformats.org/drawingml/2006/main"/>
-          <a:p xmlns:a="http://schemas.openxmlformats.org/drawingml/2006/main">
-            <a:pPr algn="l">
-              <a:lnSpc>
-                <a:spcPct val="104000"/>
-              </a:lnSpc>
-              <a:buNone/>
-            </a:pPr>
-            <a:r>
-              <a:rPr sz="1500" b="1">
-                <a:solidFill>
-                  <a:schemeClr val="tx2">
-                    <a:lumMod val="4356"/>
-                    <a:lumOff val="95644"/>
-                  </a:schemeClr>
-                </a:solidFill>
-                <a:latin typeface="Microsoft YaHei"/>
-                <a:ea typeface="Microsoft YaHei"/>
-                <a:cs typeface="Microsoft YaHei"/>
-              </a:rPr>
-              <a:t>对象不一致，价格比较就没有意义</a:t>
-            </a:r>
-            <a:endParaRPr sz="1500" b="1">
-              <a:solidFill>
-                <a:schemeClr val="tx2">
-                  <a:lumMod val="4356"/>
-                  <a:lumOff val="95644"/>
-                </a:schemeClr>
-              </a:solidFill>
-              <a:latin typeface="Microsoft YaHei"/>
-              <a:ea typeface="Microsoft YaHei"/>
-              <a:cs typeface="Microsoft YaHei"/>
-            </a:endParaRPr>
-          </a:p>
-        </p:txBody>
-      </p:sp>
-      <p:sp>
-        <p:nvSpPr>
-          <p:cNvPr id="18" name="任意多边形 17">
-            <a:extLst xmlns:a="http://schemas.openxmlformats.org/drawingml/2006/main">
-              <a:ext uri="{FF2B5EF4-FFF2-40B4-BE49-F238E27FC236}">
-                <a16:creationId xmlns:a16="http://schemas.microsoft.com/office/drawing/2014/main" id="{6380A6DB-D7A2-4D94-8F56-2B856087A254}"/>
-              </a:ext>
-            </a:extLst>
-          </p:cNvPr>
-          <p:cNvSpPr>
-            <a:spLocks xmlns:a="http://schemas.openxmlformats.org/drawingml/2006/main" noGrp="1"/>
-          </p:cNvSpPr>
-          <p:nvPr/>
-        </p:nvSpPr>
-        <p:spPr>
-          <a:xfrm xmlns:a="http://schemas.openxmlformats.org/drawingml/2006/main">
-            <a:off x="771525" y="3998595"/>
-            <a:ext cx="342900" cy="342900"/>
-          </a:xfrm>
-          <a:custGeom xmlns:a="http://schemas.openxmlformats.org/drawingml/2006/main">
-            <a:gdLst>
-              <a:gd name="sw" fmla="*/ 1 w 540"/>
-              <a:gd name="sh" fmla="*/ 1 h 540"/>
-              <a:gd name="mins" fmla="min sw sh"/>
-              <a:gd name="dsw" fmla="+- 0 sw mins"/>
-              <a:gd name="dsh" fmla="+- 0 sh mins"/>
-              <a:gd name="p0x0" fmla="*/ 120 w 540"/>
-              <a:gd name="p0y0" fmla="*/ 0 h 540"/>
-              <a:gd name="p0x1" fmla="*/ 420 w 540"/>
-              <a:gd name="p0y1" fmla="*/ 0 h 540"/>
-              <a:gd name="p0x2" fmla="*/ 486 w 540"/>
-              <a:gd name="p0y2" fmla="*/ 0 h 540"/>
-              <a:gd name="p0x3" fmla="*/ 540 w 540"/>
-              <a:gd name="p0y3" fmla="*/ 53 h 540"/>
-              <a:gd name="p0x4" fmla="*/ 540 w 540"/>
-              <a:gd name="p0y4" fmla="*/ 120 h 540"/>
-              <a:gd name="p0x5" fmla="*/ 540 w 540"/>
-              <a:gd name="p0y5" fmla="*/ 420 h 540"/>
-              <a:gd name="p0x6" fmla="*/ 540 w 540"/>
-              <a:gd name="p0y6" fmla="*/ 486 h 540"/>
-              <a:gd name="p0x7" fmla="*/ 486 w 540"/>
-              <a:gd name="p0y7" fmla="*/ 540 h 540"/>
-              <a:gd name="p0x8" fmla="*/ 420 w 540"/>
-              <a:gd name="p0y8" fmla="*/ 540 h 540"/>
-              <a:gd name="p0x9" fmla="*/ 120 w 540"/>
-              <a:gd name="p0y9" fmla="*/ 540 h 540"/>
-              <a:gd name="p0x10" fmla="*/ 53 w 540"/>
-              <a:gd name="p0y10" fmla="*/ 540 h 540"/>
-              <a:gd name="p0x11" fmla="*/ 0 w 540"/>
-              <a:gd name="p0y11" fmla="*/ 486 h 540"/>
-              <a:gd name="p0x12" fmla="*/ 0 w 540"/>
-              <a:gd name="p0y12" fmla="*/ 420 h 540"/>
-              <a:gd name="p0x13" fmla="*/ 0 w 540"/>
-              <a:gd name="p0y13" fmla="*/ 120 h 540"/>
-              <a:gd name="p0x14" fmla="*/ 0 w 540"/>
-              <a:gd name="p0y14" fmla="*/ 53 h 540"/>
-              <a:gd name="p0x15" fmla="*/ 53 w 540"/>
-              <a:gd name="p0y15" fmla="*/ 0 h 540"/>
-              <a:gd name="p0x16" fmla="*/ 120 w 540"/>
-              <a:gd name="p0y16" fmla="*/ 0 h 540"/>
-            </a:gdLst>
-            <a:pathLst>
-              <a:path w="0" h="0">
-                <a:moveTo>
-                  <a:pt x="0" y="0"/>
-                </a:moveTo>
-                <a:lnTo>
-                  <a:pt x="0" y="0"/>
-                </a:lnTo>
-                <a:cubicBezTo>
-                  <a:pt x="0" y="0"/>
-                  <a:pt x="0" y="0"/>
-                  <a:pt x="0" y="0"/>
-                </a:cubicBezTo>
-                <a:lnTo>
-                  <a:pt x="0" y="0"/>
-                </a:lnTo>
-                <a:cubicBezTo>
-                  <a:pt x="0" y="0"/>
-                  <a:pt x="0" y="0"/>
-                  <a:pt x="0" y="0"/>
-                </a:cubicBezTo>
-                <a:lnTo>
-                  <a:pt x="0" y="0"/>
-                </a:lnTo>
-                <a:cubicBezTo>
-                  <a:pt x="0" y="0"/>
-                  <a:pt x="0" y="0"/>
-                  <a:pt x="0" y="0"/>
-                </a:cubicBezTo>
-                <a:lnTo>
-                  <a:pt x="0" y="0"/>
-                </a:lnTo>
-                <a:cubicBezTo>
-                  <a:pt x="0" y="0"/>
-                  <a:pt x="0" y="0"/>
-                  <a:pt x="0" y="0"/>
-                </a:cubicBezTo>
-                <a:close/>
-              </a:path>
-            </a:pathLst>
-          </a:custGeom>
-          <a:solidFill xmlns:a="http://schemas.openxmlformats.org/drawingml/2006/main">
-            <a:schemeClr val="accent1">
-              <a:alpha val="16078"/>
-            </a:schemeClr>
-          </a:solidFill>
-          <a:ln xmlns:a="http://schemas.openxmlformats.org/drawingml/2006/main">
-            <a:noFill/>
-          </a:ln>
-        </p:spPr>
-        <p:style>
-          <a:lnRef xmlns:a="http://schemas.openxmlformats.org/drawingml/2006/main" idx="2">
-            <a:schemeClr val="accent1">
-              <a:lumMod val="75000"/>
-            </a:schemeClr>
-          </a:lnRef>
-          <a:fillRef xmlns:a="http://schemas.openxmlformats.org/drawingml/2006/main" idx="1">
-            <a:schemeClr val="accent1"/>
-          </a:fillRef>
-          <a:effectRef xmlns:a="http://schemas.openxmlformats.org/drawingml/2006/main" idx="0">
-            <a:srgbClr val="FFFFFF"/>
-          </a:effectRef>
-          <a:fontRef xmlns:a="http://schemas.openxmlformats.org/drawingml/2006/main" idx="minor">
-            <a:schemeClr val="lt1"/>
-          </a:fontRef>
-        </p:style>
-        <p:txBody>
-          <a:bodyPr xmlns:a="http://schemas.openxmlformats.org/drawingml/2006/main" anchor="ctr"/>
-          <a:lstStyle xmlns:a="http://schemas.openxmlformats.org/drawingml/2006/main"/>
-          <a:p xmlns:a="http://schemas.openxmlformats.org/drawingml/2006/main">
-            <a:pPr algn="ctr">
-              <a:buNone/>
-            </a:pPr>
-            <a:endParaRPr/>
-          </a:p>
-        </p:txBody>
-      </p:sp>
-      <p:sp>
-        <p:nvSpPr>
-          <p:cNvPr id="19" name="文本框 18">
-            <a:extLst xmlns:a="http://schemas.openxmlformats.org/drawingml/2006/main">
-              <a:ext uri="{FF2B5EF4-FFF2-40B4-BE49-F238E27FC236}">
-                <a16:creationId xmlns:a16="http://schemas.microsoft.com/office/drawing/2014/main" id="{04203D71-4CFC-44DF-86A3-C94FFE35255A}"/>
-              </a:ext>
-            </a:extLst>
-          </p:cNvPr>
-          <p:cNvSpPr>
-            <a:spLocks xmlns:a="http://schemas.openxmlformats.org/drawingml/2006/main" noGrp="1"/>
-          </p:cNvSpPr>
-          <p:nvPr/>
-        </p:nvSpPr>
-        <p:spPr>
-          <a:xfrm xmlns:a="http://schemas.openxmlformats.org/drawingml/2006/main">
-            <a:off x="812159" y="4048392"/>
-            <a:ext cx="471116" cy="239078"/>
-          </a:xfrm>
-          <a:prstGeom xmlns:a="http://schemas.openxmlformats.org/drawingml/2006/main" prst="rect">
-            <a:avLst/>
-          </a:prstGeom>
-          <a:noFill xmlns:a="http://schemas.openxmlformats.org/drawingml/2006/main"/>
-        </p:spPr>
-        <p:txBody>
-          <a:bodyPr xmlns:a="http://schemas.openxmlformats.org/drawingml/2006/main" wrap="square" lIns="0" tIns="0" rIns="0" bIns="0" anchor="t">
-            <a:noAutofit/>
-          </a:bodyPr>
-          <a:lstStyle xmlns:a="http://schemas.openxmlformats.org/drawingml/2006/main"/>
-          <a:p xmlns:a="http://schemas.openxmlformats.org/drawingml/2006/main">
-            <a:pPr algn="l">
-              <a:lnSpc>
-                <a:spcPct val="83000"/>
-              </a:lnSpc>
-              <a:buNone/>
-            </a:pPr>
-            <a:r>
-              <a:rPr sz="1650" b="1">
-                <a:solidFill>
-                  <a:srgbClr val="AF753D"/>
-                </a:solidFill>
-                <a:latin typeface="Microsoft YaHei"/>
-                <a:ea typeface="Microsoft YaHei"/>
-                <a:cs typeface="Microsoft YaHei"/>
-              </a:rPr>
-              <a:t>05</a:t>
-            </a:r>
-            <a:endParaRPr sz="1650" b="1">
-              <a:solidFill>
-                <a:srgbClr val="AF753D"/>
-              </a:solidFill>
-              <a:latin typeface="Microsoft YaHei"/>
-              <a:ea typeface="Microsoft YaHei"/>
-              <a:cs typeface="Microsoft YaHei"/>
-            </a:endParaRPr>
-          </a:p>
-        </p:txBody>
-      </p:sp>
-      <p:sp>
-        <p:nvSpPr>
-          <p:cNvPr id="20" name="文本框 19">
-            <a:extLst xmlns:a="http://schemas.openxmlformats.org/drawingml/2006/main">
-              <a:ext uri="{FF2B5EF4-FFF2-40B4-BE49-F238E27FC236}">
-                <a16:creationId xmlns:a16="http://schemas.microsoft.com/office/drawing/2014/main" id="{229F6069-1012-48E7-B766-A7B8CCDAF6BC}"/>
-              </a:ext>
-            </a:extLst>
-          </p:cNvPr>
-          <p:cNvSpPr>
-            <a:spLocks xmlns:a="http://schemas.openxmlformats.org/drawingml/2006/main" noGrp="1"/>
-          </p:cNvSpPr>
-          <p:nvPr/>
-        </p:nvSpPr>
-        <p:spPr>
-          <a:xfrm xmlns:a="http://schemas.openxmlformats.org/drawingml/2006/main">
-            <a:off x="1228725" y="4036962"/>
-            <a:ext cx="2286000" cy="261938"/>
-          </a:xfrm>
-          <a:prstGeom xmlns:a="http://schemas.openxmlformats.org/drawingml/2006/main" prst="rect">
-            <a:avLst/>
-          </a:prstGeom>
-          <a:noFill xmlns:a="http://schemas.openxmlformats.org/drawingml/2006/main"/>
-        </p:spPr>
-        <p:txBody>
-          <a:bodyPr xmlns:a="http://schemas.openxmlformats.org/drawingml/2006/main" wrap="square" lIns="0" tIns="0" rIns="0" bIns="0" anchor="t">
-            <a:noAutofit/>
-          </a:bodyPr>
-          <a:lstStyle xmlns:a="http://schemas.openxmlformats.org/drawingml/2006/main"/>
-          <a:p xmlns:a="http://schemas.openxmlformats.org/drawingml/2006/main">
-            <a:pPr algn="l">
-              <a:lnSpc>
-                <a:spcPct val="104000"/>
-              </a:lnSpc>
-              <a:buNone/>
-            </a:pPr>
-            <a:r>
-              <a:rPr sz="1500" b="1">
-                <a:solidFill>
-                  <a:schemeClr val="tx2">
-                    <a:lumMod val="4356"/>
-                    <a:lumOff val="95644"/>
-                  </a:schemeClr>
-                </a:solidFill>
-                <a:latin typeface="Microsoft YaHei"/>
-                <a:ea typeface="Microsoft YaHei"/>
-                <a:cs typeface="Microsoft YaHei"/>
-              </a:rPr>
-              <a:t>低价可能来自不同 SKU</a:t>
-            </a:r>
-            <a:endParaRPr sz="1500" b="1">
-              <a:solidFill>
-                <a:schemeClr val="tx2">
-                  <a:lumMod val="4356"/>
-                  <a:lumOff val="95644"/>
-                </a:schemeClr>
-              </a:solidFill>
-              <a:latin typeface="Microsoft YaHei"/>
-              <a:ea typeface="Microsoft YaHei"/>
-              <a:cs typeface="Microsoft YaHei"/>
-            </a:endParaRPr>
-          </a:p>
-        </p:txBody>
-      </p:sp>
-      <p:sp>
-        <p:nvSpPr>
-          <p:cNvPr id="21" name="任意多边形 20">
-            <a:extLst xmlns:a="http://schemas.openxmlformats.org/drawingml/2006/main">
-              <a:ext uri="{FF2B5EF4-FFF2-40B4-BE49-F238E27FC236}">
-                <a16:creationId xmlns:a16="http://schemas.microsoft.com/office/drawing/2014/main" id="{E5E0320B-5C68-49D7-9D07-666D0C53A214}"/>
-              </a:ext>
-            </a:extLst>
-          </p:cNvPr>
-          <p:cNvSpPr>
-            <a:spLocks xmlns:a="http://schemas.openxmlformats.org/drawingml/2006/main" noGrp="1"/>
-          </p:cNvSpPr>
-          <p:nvPr/>
-        </p:nvSpPr>
-        <p:spPr>
-          <a:xfrm xmlns:a="http://schemas.openxmlformats.org/drawingml/2006/main">
-            <a:off x="771525" y="4538980"/>
-            <a:ext cx="342900" cy="342900"/>
-          </a:xfrm>
-          <a:custGeom xmlns:a="http://schemas.openxmlformats.org/drawingml/2006/main">
-            <a:gdLst>
-              <a:gd name="sw" fmla="*/ 1 w 540"/>
-              <a:gd name="sh" fmla="*/ 1 h 540"/>
-              <a:gd name="mins" fmla="min sw sh"/>
-              <a:gd name="dsw" fmla="+- 0 sw mins"/>
-              <a:gd name="dsh" fmla="+- 0 sh mins"/>
-              <a:gd name="p0x0" fmla="*/ 120 w 540"/>
-              <a:gd name="p0y0" fmla="*/ 0 h 540"/>
-              <a:gd name="p0x1" fmla="*/ 420 w 540"/>
-              <a:gd name="p0y1" fmla="*/ 0 h 540"/>
-              <a:gd name="p0x2" fmla="*/ 486 w 540"/>
-              <a:gd name="p0y2" fmla="*/ 0 h 540"/>
-              <a:gd name="p0x3" fmla="*/ 540 w 540"/>
-              <a:gd name="p0y3" fmla="*/ 53 h 540"/>
-              <a:gd name="p0x4" fmla="*/ 540 w 540"/>
-              <a:gd name="p0y4" fmla="*/ 120 h 540"/>
-              <a:gd name="p0x5" fmla="*/ 540 w 540"/>
-              <a:gd name="p0y5" fmla="*/ 420 h 540"/>
-              <a:gd name="p0x6" fmla="*/ 540 w 540"/>
-              <a:gd name="p0y6" fmla="*/ 486 h 540"/>
-              <a:gd name="p0x7" fmla="*/ 486 w 540"/>
-              <a:gd name="p0y7" fmla="*/ 540 h 540"/>
-              <a:gd name="p0x8" fmla="*/ 420 w 540"/>
-              <a:gd name="p0y8" fmla="*/ 540 h 540"/>
-              <a:gd name="p0x9" fmla="*/ 120 w 540"/>
-              <a:gd name="p0y9" fmla="*/ 540 h 540"/>
-              <a:gd name="p0x10" fmla="*/ 53 w 540"/>
-              <a:gd name="p0y10" fmla="*/ 540 h 540"/>
-              <a:gd name="p0x11" fmla="*/ 0 w 540"/>
-              <a:gd name="p0y11" fmla="*/ 486 h 540"/>
-              <a:gd name="p0x12" fmla="*/ 0 w 540"/>
-              <a:gd name="p0y12" fmla="*/ 420 h 540"/>
-              <a:gd name="p0x13" fmla="*/ 0 w 540"/>
-              <a:gd name="p0y13" fmla="*/ 120 h 540"/>
-              <a:gd name="p0x14" fmla="*/ 0 w 540"/>
-              <a:gd name="p0y14" fmla="*/ 53 h 540"/>
-              <a:gd name="p0x15" fmla="*/ 53 w 540"/>
-              <a:gd name="p0y15" fmla="*/ 0 h 540"/>
-              <a:gd name="p0x16" fmla="*/ 120 w 540"/>
-              <a:gd name="p0y16" fmla="*/ 0 h 540"/>
-            </a:gdLst>
-            <a:pathLst>
-              <a:path w="0" h="0">
-                <a:moveTo>
-                  <a:pt x="0" y="0"/>
-                </a:moveTo>
-                <a:lnTo>
-                  <a:pt x="0" y="0"/>
-                </a:lnTo>
-                <a:cubicBezTo>
-                  <a:pt x="0" y="0"/>
-                  <a:pt x="0" y="0"/>
-                  <a:pt x="0" y="0"/>
-                </a:cubicBezTo>
-                <a:lnTo>
-                  <a:pt x="0" y="0"/>
-                </a:lnTo>
-                <a:cubicBezTo>
-                  <a:pt x="0" y="0"/>
-                  <a:pt x="0" y="0"/>
-                  <a:pt x="0" y="0"/>
-                </a:cubicBezTo>
-                <a:lnTo>
-                  <a:pt x="0" y="0"/>
-                </a:lnTo>
-                <a:cubicBezTo>
-                  <a:pt x="0" y="0"/>
-                  <a:pt x="0" y="0"/>
-                  <a:pt x="0" y="0"/>
-                </a:cubicBezTo>
-                <a:lnTo>
-                  <a:pt x="0" y="0"/>
-                </a:lnTo>
-                <a:cubicBezTo>
-                  <a:pt x="0" y="0"/>
-                  <a:pt x="0" y="0"/>
-                  <a:pt x="0" y="0"/>
-                </a:cubicBezTo>
-                <a:close/>
-              </a:path>
-            </a:pathLst>
-          </a:custGeom>
-          <a:solidFill xmlns:a="http://schemas.openxmlformats.org/drawingml/2006/main">
-            <a:schemeClr val="accent1">
-              <a:alpha val="16078"/>
-            </a:schemeClr>
-          </a:solidFill>
-          <a:ln xmlns:a="http://schemas.openxmlformats.org/drawingml/2006/main">
-            <a:noFill/>
-          </a:ln>
-        </p:spPr>
-        <p:style>
-          <a:lnRef xmlns:a="http://schemas.openxmlformats.org/drawingml/2006/main" idx="2">
-            <a:schemeClr val="accent1">
-              <a:lumMod val="75000"/>
-            </a:schemeClr>
-          </a:lnRef>
-          <a:fillRef xmlns:a="http://schemas.openxmlformats.org/drawingml/2006/main" idx="1">
-            <a:schemeClr val="accent1"/>
-          </a:fillRef>
-          <a:effectRef xmlns:a="http://schemas.openxmlformats.org/drawingml/2006/main" idx="0">
-            <a:srgbClr val="FFFFFF"/>
-          </a:effectRef>
-          <a:fontRef xmlns:a="http://schemas.openxmlformats.org/drawingml/2006/main" idx="minor">
-            <a:schemeClr val="lt1"/>
-          </a:fontRef>
-        </p:style>
-        <p:txBody>
-          <a:bodyPr xmlns:a="http://schemas.openxmlformats.org/drawingml/2006/main" anchor="ctr"/>
-          <a:lstStyle xmlns:a="http://schemas.openxmlformats.org/drawingml/2006/main"/>
-          <a:p xmlns:a="http://schemas.openxmlformats.org/drawingml/2006/main">
-            <a:pPr algn="ctr">
-              <a:buNone/>
-            </a:pPr>
-            <a:endParaRPr/>
-          </a:p>
-        </p:txBody>
-      </p:sp>
-      <p:sp>
-        <p:nvSpPr>
-          <p:cNvPr id="22" name="文本框 21">
-            <a:extLst xmlns:a="http://schemas.openxmlformats.org/drawingml/2006/main">
-              <a:ext uri="{FF2B5EF4-FFF2-40B4-BE49-F238E27FC236}">
-                <a16:creationId xmlns:a16="http://schemas.microsoft.com/office/drawing/2014/main" id="{7EA51F42-7EF7-4019-B703-23280DE3CE81}"/>
-              </a:ext>
-            </a:extLst>
-          </p:cNvPr>
-          <p:cNvSpPr>
-            <a:spLocks xmlns:a="http://schemas.openxmlformats.org/drawingml/2006/main" noGrp="1"/>
-          </p:cNvSpPr>
-          <p:nvPr/>
-        </p:nvSpPr>
-        <p:spPr>
-          <a:xfrm xmlns:a="http://schemas.openxmlformats.org/drawingml/2006/main">
-            <a:off x="812159" y="4589088"/>
-            <a:ext cx="471116" cy="239078"/>
-          </a:xfrm>
-          <a:prstGeom xmlns:a="http://schemas.openxmlformats.org/drawingml/2006/main" prst="rect">
-            <a:avLst/>
-          </a:prstGeom>
-          <a:noFill xmlns:a="http://schemas.openxmlformats.org/drawingml/2006/main"/>
-        </p:spPr>
-        <p:txBody>
-          <a:bodyPr xmlns:a="http://schemas.openxmlformats.org/drawingml/2006/main" wrap="square" lIns="0" tIns="0" rIns="0" bIns="0" anchor="t">
-            <a:noAutofit/>
-          </a:bodyPr>
-          <a:lstStyle xmlns:a="http://schemas.openxmlformats.org/drawingml/2006/main"/>
-          <a:p xmlns:a="http://schemas.openxmlformats.org/drawingml/2006/main">
-            <a:pPr algn="l">
-              <a:lnSpc>
-                <a:spcPct val="83000"/>
-              </a:lnSpc>
-              <a:buNone/>
-            </a:pPr>
-            <a:r>
-              <a:rPr sz="1650" b="1">
-                <a:solidFill>
-                  <a:srgbClr val="AF753D"/>
-                </a:solidFill>
-                <a:latin typeface="Microsoft YaHei"/>
-                <a:ea typeface="Microsoft YaHei"/>
-                <a:cs typeface="Microsoft YaHei"/>
-              </a:rPr>
-              <a:t>06</a:t>
-            </a:r>
-            <a:endParaRPr sz="1650" b="1">
-              <a:solidFill>
-                <a:srgbClr val="AF753D"/>
-              </a:solidFill>
-              <a:latin typeface="Microsoft YaHei"/>
-              <a:ea typeface="Microsoft YaHei"/>
-              <a:cs typeface="Microsoft YaHei"/>
-            </a:endParaRPr>
-          </a:p>
-        </p:txBody>
-      </p:sp>
-      <p:sp>
-        <p:nvSpPr>
-          <p:cNvPr id="23" name="文本框 22">
-            <a:extLst xmlns:a="http://schemas.openxmlformats.org/drawingml/2006/main">
-              <a:ext uri="{FF2B5EF4-FFF2-40B4-BE49-F238E27FC236}">
-                <a16:creationId xmlns:a16="http://schemas.microsoft.com/office/drawing/2014/main" id="{D6B3F36E-1BCE-4DD3-97F0-04303910E6A8}"/>
-              </a:ext>
-            </a:extLst>
-          </p:cNvPr>
-          <p:cNvSpPr>
-            <a:spLocks xmlns:a="http://schemas.openxmlformats.org/drawingml/2006/main" noGrp="1"/>
-          </p:cNvSpPr>
-          <p:nvPr/>
-        </p:nvSpPr>
-        <p:spPr>
-          <a:xfrm xmlns:a="http://schemas.openxmlformats.org/drawingml/2006/main">
-            <a:off x="1228725" y="4577658"/>
-            <a:ext cx="2857500" cy="261938"/>
-          </a:xfrm>
-          <a:prstGeom xmlns:a="http://schemas.openxmlformats.org/drawingml/2006/main" prst="rect">
-            <a:avLst/>
-          </a:prstGeom>
-          <a:noFill xmlns:a="http://schemas.openxmlformats.org/drawingml/2006/main"/>
-        </p:spPr>
-        <p:txBody>
-          <a:bodyPr xmlns:a="http://schemas.openxmlformats.org/drawingml/2006/main" wrap="square" lIns="0" tIns="0" rIns="0" bIns="0" anchor="t">
-            <a:noAutofit/>
-          </a:bodyPr>
-          <a:lstStyle xmlns:a="http://schemas.openxmlformats.org/drawingml/2006/main"/>
-          <a:p xmlns:a="http://schemas.openxmlformats.org/drawingml/2006/main">
-            <a:pPr algn="l">
-              <a:lnSpc>
-                <a:spcPct val="104000"/>
-              </a:lnSpc>
-              <a:buNone/>
-            </a:pPr>
-            <a:r>
-              <a:rPr sz="1500" b="1">
-                <a:solidFill>
-                  <a:schemeClr val="tx2">
-                    <a:lumMod val="4356"/>
-                    <a:lumOff val="95644"/>
-                  </a:schemeClr>
-                </a:solidFill>
-                <a:latin typeface="Microsoft YaHei"/>
-                <a:ea typeface="Microsoft YaHei"/>
-                <a:cs typeface="Microsoft YaHei"/>
-              </a:rPr>
-              <a:t>推荐必须给出可核验依据</a:t>
-            </a:r>
-            <a:endParaRPr sz="1500" b="1">
-              <a:solidFill>
-                <a:schemeClr val="tx2">
-                  <a:lumMod val="4356"/>
-                  <a:lumOff val="95644"/>
-                </a:schemeClr>
-              </a:solidFill>
-              <a:latin typeface="Microsoft YaHei"/>
-              <a:ea typeface="Microsoft YaHei"/>
-              <a:cs typeface="Microsoft YaHei"/>
-            </a:endParaRPr>
-          </a:p>
-        </p:txBody>
-      </p:sp>
-      <p:sp>
-        <p:nvSpPr>
-          <p:cNvPr id="24" name="任意多边形 23">
-            <a:extLst xmlns:a="http://schemas.openxmlformats.org/drawingml/2006/main">
-              <a:ext uri="{FF2B5EF4-FFF2-40B4-BE49-F238E27FC236}">
-                <a16:creationId xmlns:a16="http://schemas.microsoft.com/office/drawing/2014/main" id="{9A790A62-E182-4022-BB32-82B501AF7E4C}"/>
-              </a:ext>
-            </a:extLst>
-          </p:cNvPr>
-          <p:cNvSpPr>
-            <a:spLocks xmlns:a="http://schemas.openxmlformats.org/drawingml/2006/main" noGrp="1"/>
-          </p:cNvSpPr>
-          <p:nvPr/>
-        </p:nvSpPr>
-        <p:spPr>
-          <a:xfrm xmlns:a="http://schemas.openxmlformats.org/drawingml/2006/main">
-            <a:off x="6214745" y="1109345"/>
-            <a:ext cx="5400675" cy="4090035"/>
-          </a:xfrm>
-          <a:custGeom xmlns:a="http://schemas.openxmlformats.org/drawingml/2006/main">
-            <a:gdLst>
-              <a:gd name="sw" fmla="*/ 1 w 8505"/>
-              <a:gd name="sh" fmla="*/ 1 h 6440"/>
-              <a:gd name="mins" fmla="min sw sh"/>
-              <a:gd name="dsw" fmla="+- 0 sw mins"/>
-              <a:gd name="dsh" fmla="+- 0 sh mins"/>
-              <a:gd name="p0x0" fmla="*/ 120 w 8505"/>
-              <a:gd name="p0y0" fmla="*/ 0 h 6440"/>
-              <a:gd name="p0x1" fmla="*/ 8385 w 8505"/>
-              <a:gd name="p0y1" fmla="*/ 0 h 6440"/>
-              <a:gd name="p0x2" fmla="*/ 8451 w 8505"/>
-              <a:gd name="p0y2" fmla="*/ 0 h 6440"/>
-              <a:gd name="p0x3" fmla="*/ 8505 w 8505"/>
-              <a:gd name="p0y3" fmla="*/ 53 h 6440"/>
-              <a:gd name="p0x4" fmla="*/ 8505 w 8505"/>
-              <a:gd name="p0y4" fmla="*/ 120 h 6440"/>
-              <a:gd name="p0x5" fmla="*/ 8505 w 8505"/>
-              <a:gd name="p0y5" fmla="*/ 6320 h 6440"/>
-              <a:gd name="p0x6" fmla="*/ 8505 w 8505"/>
-              <a:gd name="p0y6" fmla="*/ 6387 h 6440"/>
-              <a:gd name="p0x7" fmla="*/ 8451 w 8505"/>
-              <a:gd name="p0y7" fmla="*/ 6440 h 6440"/>
-              <a:gd name="p0x8" fmla="*/ 8385 w 8505"/>
-              <a:gd name="p0y8" fmla="*/ 6440 h 6440"/>
-              <a:gd name="p0x9" fmla="*/ 120 w 8505"/>
-              <a:gd name="p0y9" fmla="*/ 6440 h 6440"/>
-              <a:gd name="p0x10" fmla="*/ 53 w 8505"/>
-              <a:gd name="p0y10" fmla="*/ 6440 h 6440"/>
-              <a:gd name="p0x11" fmla="*/ 0 w 8505"/>
-              <a:gd name="p0y11" fmla="*/ 6387 h 6440"/>
-              <a:gd name="p0x12" fmla="*/ 0 w 8505"/>
-              <a:gd name="p0y12" fmla="*/ 6320 h 6440"/>
-              <a:gd name="p0x13" fmla="*/ 0 w 8505"/>
-              <a:gd name="p0y13" fmla="*/ 120 h 6440"/>
-              <a:gd name="p0x14" fmla="*/ 0 w 8505"/>
-              <a:gd name="p0y14" fmla="*/ 53 h 6440"/>
-              <a:gd name="p0x15" fmla="*/ 53 w 8505"/>
-              <a:gd name="p0y15" fmla="*/ 0 h 6440"/>
-              <a:gd name="p0x16" fmla="*/ 120 w 8505"/>
-              <a:gd name="p0y16" fmla="*/ 0 h 6440"/>
-            </a:gdLst>
-            <a:pathLst>
-              <a:path w="0" h="0">
-                <a:moveTo>
-                  <a:pt x="0" y="0"/>
-                </a:moveTo>
-                <a:lnTo>
-                  <a:pt x="0" y="0"/>
-                </a:lnTo>
-                <a:cubicBezTo>
-                  <a:pt x="0" y="0"/>
-                  <a:pt x="0" y="0"/>
-                  <a:pt x="0" y="0"/>
-                </a:cubicBezTo>
-                <a:lnTo>
-                  <a:pt x="0" y="0"/>
-                </a:lnTo>
-                <a:cubicBezTo>
-                  <a:pt x="0" y="0"/>
-                  <a:pt x="0" y="0"/>
-                  <a:pt x="0" y="0"/>
-                </a:cubicBezTo>
-                <a:lnTo>
-                  <a:pt x="0" y="0"/>
-                </a:lnTo>
-                <a:cubicBezTo>
-                  <a:pt x="0" y="0"/>
-                  <a:pt x="0" y="0"/>
-                  <a:pt x="0" y="0"/>
-                </a:cubicBezTo>
-                <a:lnTo>
-                  <a:pt x="0" y="0"/>
-                </a:lnTo>
-                <a:cubicBezTo>
-                  <a:pt x="0" y="0"/>
-                  <a:pt x="0" y="0"/>
-                  <a:pt x="0" y="0"/>
-                </a:cubicBezTo>
-                <a:close/>
-              </a:path>
-            </a:pathLst>
-          </a:custGeom>
-          <a:solidFill xmlns:a="http://schemas.openxmlformats.org/drawingml/2006/main">
-            <a:srgbClr val="FFFFFF">
-              <a:alpha val="10980"/>
-            </a:srgbClr>
-          </a:solidFill>
-          <a:ln xmlns:a="http://schemas.openxmlformats.org/drawingml/2006/main" w="9525" cmpd="sng">
-            <a:solidFill>
-              <a:srgbClr val="FFFFFF">
-                <a:alpha val="10980"/>
-              </a:srgbClr>
-            </a:solidFill>
-            <a:prstDash val="solid"/>
-          </a:ln>
-          <a:effectLst xmlns:a="http://schemas.openxmlformats.org/drawingml/2006/main">
-            <a:outerShdw blurRad="142875" algn="ctr" rotWithShape="0">
-              <a:schemeClr val="accent2">
-                <a:alpha val="12157"/>
-              </a:schemeClr>
-            </a:outerShdw>
-          </a:effectLst>
-        </p:spPr>
-        <p:style>
-          <a:lnRef xmlns:a="http://schemas.openxmlformats.org/drawingml/2006/main" idx="2">
-            <a:schemeClr val="accent1">
-              <a:lumMod val="75000"/>
-            </a:schemeClr>
-          </a:lnRef>
-          <a:fillRef xmlns:a="http://schemas.openxmlformats.org/drawingml/2006/main" idx="1">
-            <a:schemeClr val="accent1"/>
-          </a:fillRef>
-          <a:effectRef xmlns:a="http://schemas.openxmlformats.org/drawingml/2006/main" idx="0">
-            <a:srgbClr val="FFFFFF"/>
-          </a:effectRef>
-          <a:fontRef xmlns:a="http://schemas.openxmlformats.org/drawingml/2006/main" idx="minor">
-            <a:schemeClr val="lt1"/>
-          </a:fontRef>
-        </p:style>
-        <p:txBody>
-          <a:bodyPr xmlns:a="http://schemas.openxmlformats.org/drawingml/2006/main" anchor="ctr"/>
-          <a:lstStyle xmlns:a="http://schemas.openxmlformats.org/drawingml/2006/main"/>
-          <a:p xmlns:a="http://schemas.openxmlformats.org/drawingml/2006/main">
-            <a:pPr algn="ctr">
-              <a:buNone/>
-            </a:pPr>
-            <a:endParaRPr/>
-          </a:p>
-        </p:txBody>
-      </p:sp>
-      <p:sp>
-        <p:nvSpPr>
-          <p:cNvPr id="25" name="文本框 24">
-            <a:extLst xmlns:a="http://schemas.openxmlformats.org/drawingml/2006/main">
-              <a:ext uri="{FF2B5EF4-FFF2-40B4-BE49-F238E27FC236}">
-                <a16:creationId xmlns:a16="http://schemas.microsoft.com/office/drawing/2014/main" id="{459D5196-1B47-45DC-8B4D-4B19EE49C049}"/>
-              </a:ext>
-            </a:extLst>
-          </p:cNvPr>
-          <p:cNvSpPr>
-            <a:spLocks xmlns:a="http://schemas.openxmlformats.org/drawingml/2006/main" noGrp="1"/>
-          </p:cNvSpPr>
-          <p:nvPr/>
-        </p:nvSpPr>
-        <p:spPr>
-          <a:xfrm xmlns:a="http://schemas.openxmlformats.org/drawingml/2006/main">
-            <a:off x="6410325" y="1288732"/>
-            <a:ext cx="5010150" cy="365760"/>
-          </a:xfrm>
-          <a:prstGeom xmlns:a="http://schemas.openxmlformats.org/drawingml/2006/main" prst="rect">
-            <a:avLst/>
-          </a:prstGeom>
-          <a:noFill xmlns:a="http://schemas.openxmlformats.org/drawingml/2006/main"/>
-        </p:spPr>
-        <p:txBody>
-          <a:bodyPr xmlns:a="http://schemas.openxmlformats.org/drawingml/2006/main" wrap="square" lIns="0" tIns="0" rIns="0" bIns="0" anchor="t">
-            <a:noAutofit/>
-          </a:bodyPr>
-          <a:lstStyle xmlns:a="http://schemas.openxmlformats.org/drawingml/2006/main"/>
-          <a:p xmlns:a="http://schemas.openxmlformats.org/drawingml/2006/main">
-            <a:pPr algn="l">
-              <a:lnSpc>
-                <a:spcPct val="104000"/>
-              </a:lnSpc>
-              <a:buNone/>
-            </a:pPr>
-            <a:r>
-              <a:rPr sz="2100" b="1" spc="42">
-                <a:solidFill>
-                  <a:srgbClr val="F4F4F5"/>
-                </a:solidFill>
-                <a:latin typeface="Microsoft YaHei"/>
-                <a:ea typeface="Microsoft YaHei"/>
-                <a:cs typeface="Microsoft YaHei"/>
-              </a:rPr>
-              <a:t>四步锁定可比商品</a:t>
-            </a:r>
-            <a:endParaRPr sz="2100" b="1" spc="42">
-              <a:solidFill>
-                <a:srgbClr val="F4F4F5"/>
-              </a:solidFill>
-              <a:latin typeface="Microsoft YaHei"/>
-              <a:ea typeface="Microsoft YaHei"/>
-              <a:cs typeface="Microsoft YaHei"/>
-            </a:endParaRPr>
-          </a:p>
-        </p:txBody>
-      </p:sp>
-      <p:sp>
-        <p:nvSpPr>
-          <p:cNvPr id="26" name="文本框 25">
-            <a:extLst xmlns:a="http://schemas.openxmlformats.org/drawingml/2006/main">
-              <a:ext uri="{FF2B5EF4-FFF2-40B4-BE49-F238E27FC236}">
-                <a16:creationId xmlns:a16="http://schemas.microsoft.com/office/drawing/2014/main" id="{DF9C41FF-50A7-4AE2-AC43-8C06A66E0B6E}"/>
-              </a:ext>
-            </a:extLst>
-          </p:cNvPr>
-          <p:cNvSpPr>
-            <a:spLocks xmlns:a="http://schemas.openxmlformats.org/drawingml/2006/main" noGrp="1"/>
-          </p:cNvSpPr>
-          <p:nvPr/>
-        </p:nvSpPr>
-        <p:spPr>
-          <a:xfrm xmlns:a="http://schemas.openxmlformats.org/drawingml/2006/main">
-            <a:off x="8482232" y="1679258"/>
-            <a:ext cx="1399651" cy="651510"/>
-          </a:xfrm>
-          <a:prstGeom xmlns:a="http://schemas.openxmlformats.org/drawingml/2006/main" prst="rect">
-            <a:avLst/>
-          </a:prstGeom>
-          <a:noFill xmlns:a="http://schemas.openxmlformats.org/drawingml/2006/main"/>
-        </p:spPr>
-        <p:txBody>
-          <a:bodyPr xmlns:a="http://schemas.openxmlformats.org/drawingml/2006/main" wrap="square" lIns="0" tIns="0" rIns="0" bIns="0" anchor="t">
-            <a:noAutofit/>
-          </a:bodyPr>
-          <a:lstStyle xmlns:a="http://schemas.openxmlformats.org/drawingml/2006/main"/>
-          <a:p xmlns:a="http://schemas.openxmlformats.org/drawingml/2006/main">
-            <a:pPr algn="l">
-              <a:lnSpc>
-                <a:spcPct val="92000"/>
-              </a:lnSpc>
-              <a:buNone/>
-            </a:pPr>
-            <a:r>
-              <a:rPr sz="4200" b="1">
-                <a:solidFill>
-                  <a:srgbClr val="F06666"/>
-                </a:solidFill>
-                <a:latin typeface="Microsoft YaHei"/>
-                <a:ea typeface="Microsoft YaHei"/>
-                <a:cs typeface="Microsoft YaHei"/>
-              </a:rPr>
-              <a:t>4步</a:t>
-            </a:r>
-            <a:endParaRPr sz="2100" b="1">
-              <a:solidFill>
-                <a:srgbClr val="F06666"/>
-              </a:solidFill>
-              <a:latin typeface="Microsoft YaHei"/>
-              <a:ea typeface="Microsoft YaHei"/>
-              <a:cs typeface="Microsoft YaHei"/>
-            </a:endParaRPr>
-          </a:p>
-        </p:txBody>
-      </p:sp>
-      <p:sp>
-        <p:nvSpPr>
-          <p:cNvPr id="27" name="文本框 26">
-            <a:extLst xmlns:a="http://schemas.openxmlformats.org/drawingml/2006/main">
-              <a:ext uri="{FF2B5EF4-FFF2-40B4-BE49-F238E27FC236}">
-                <a16:creationId xmlns:a16="http://schemas.microsoft.com/office/drawing/2014/main" id="{DC2CB989-CD7C-4D55-BDD6-EEEB1AAE50A1}"/>
-              </a:ext>
-            </a:extLst>
-          </p:cNvPr>
-          <p:cNvSpPr>
-            <a:spLocks xmlns:a="http://schemas.openxmlformats.org/drawingml/2006/main" noGrp="1"/>
-          </p:cNvSpPr>
-          <p:nvPr/>
-        </p:nvSpPr>
-        <p:spPr>
-          <a:xfrm xmlns:a="http://schemas.openxmlformats.org/drawingml/2006/main">
-            <a:off x="8315249" y="2339283"/>
-            <a:ext cx="1371676" cy="228600"/>
-          </a:xfrm>
-          <a:prstGeom xmlns:a="http://schemas.openxmlformats.org/drawingml/2006/main" prst="rect">
-            <a:avLst/>
-          </a:prstGeom>
-          <a:noFill xmlns:a="http://schemas.openxmlformats.org/drawingml/2006/main"/>
-        </p:spPr>
-        <p:txBody>
-          <a:bodyPr xmlns:a="http://schemas.openxmlformats.org/drawingml/2006/main" wrap="square" lIns="0" tIns="0" rIns="0" bIns="0" anchor="t">
-            <a:noAutofit/>
-          </a:bodyPr>
-          <a:lstStyle xmlns:a="http://schemas.openxmlformats.org/drawingml/2006/main"/>
-          <a:p xmlns:a="http://schemas.openxmlformats.org/drawingml/2006/main">
-            <a:pPr algn="l">
-              <a:buNone/>
-            </a:pPr>
-            <a:r>
-              <a:rPr sz="1350">
-                <a:solidFill>
-                  <a:schemeClr val="tx2">
-                    <a:lumMod val="0"/>
-                    <a:lumOff val="100000"/>
-                    <a:alpha val="72157"/>
-                  </a:schemeClr>
-                </a:solidFill>
-                <a:latin typeface="Microsoft YaHei"/>
-                <a:ea typeface="Microsoft YaHei"/>
-                <a:cs typeface="Microsoft YaHei"/>
-              </a:rPr>
-              <a:t>识别 → 约束 → 检索 → 决策</a:t>
-            </a:r>
-            <a:endParaRPr sz="1350">
-              <a:solidFill>
-                <a:schemeClr val="tx2">
-                  <a:lumMod val="0"/>
-                  <a:lumOff val="100000"/>
-                  <a:alpha val="72157"/>
-                </a:schemeClr>
-              </a:solidFill>
-              <a:latin typeface="Microsoft YaHei"/>
-              <a:ea typeface="Microsoft YaHei"/>
-              <a:cs typeface="Microsoft YaHei"/>
-            </a:endParaRPr>
-          </a:p>
-        </p:txBody>
-      </p:sp>
-      <p:sp>
-        <p:nvSpPr>
-          <p:cNvPr id="28" name="任意多边形 27">
-            <a:extLst xmlns:a="http://schemas.openxmlformats.org/drawingml/2006/main">
-              <a:ext uri="{FF2B5EF4-FFF2-40B4-BE49-F238E27FC236}">
-                <a16:creationId xmlns:a16="http://schemas.microsoft.com/office/drawing/2014/main" id="{099EE417-C943-440B-BDB6-92DBBCD3968A}"/>
-              </a:ext>
-            </a:extLst>
-          </p:cNvPr>
-          <p:cNvSpPr>
-            <a:spLocks xmlns:a="http://schemas.openxmlformats.org/drawingml/2006/main" noGrp="1"/>
-          </p:cNvSpPr>
-          <p:nvPr/>
-        </p:nvSpPr>
-        <p:spPr>
-          <a:xfrm xmlns:a="http://schemas.openxmlformats.org/drawingml/2006/main">
-            <a:off x="6410325" y="2710180"/>
-            <a:ext cx="342900" cy="342900"/>
-          </a:xfrm>
-          <a:custGeom xmlns:a="http://schemas.openxmlformats.org/drawingml/2006/main">
-            <a:gdLst>
-              <a:gd name="sw" fmla="*/ 1 w 540"/>
-              <a:gd name="sh" fmla="*/ 1 h 540"/>
-              <a:gd name="mins" fmla="min sw sh"/>
-              <a:gd name="dsw" fmla="+- 0 sw mins"/>
-              <a:gd name="dsh" fmla="+- 0 sh mins"/>
-              <a:gd name="p0x0" fmla="*/ 120 w 540"/>
-              <a:gd name="p0y0" fmla="*/ 0 h 540"/>
-              <a:gd name="p0x1" fmla="*/ 420 w 540"/>
-              <a:gd name="p0y1" fmla="*/ 0 h 540"/>
-              <a:gd name="p0x2" fmla="*/ 486 w 540"/>
-              <a:gd name="p0y2" fmla="*/ 0 h 540"/>
-              <a:gd name="p0x3" fmla="*/ 540 w 540"/>
-              <a:gd name="p0y3" fmla="*/ 53 h 540"/>
-              <a:gd name="p0x4" fmla="*/ 540 w 540"/>
-              <a:gd name="p0y4" fmla="*/ 120 h 540"/>
-              <a:gd name="p0x5" fmla="*/ 540 w 540"/>
-              <a:gd name="p0y5" fmla="*/ 420 h 540"/>
-              <a:gd name="p0x6" fmla="*/ 540 w 540"/>
-              <a:gd name="p0y6" fmla="*/ 486 h 540"/>
-              <a:gd name="p0x7" fmla="*/ 486 w 540"/>
-              <a:gd name="p0y7" fmla="*/ 540 h 540"/>
-              <a:gd name="p0x8" fmla="*/ 420 w 540"/>
-              <a:gd name="p0y8" fmla="*/ 540 h 540"/>
-              <a:gd name="p0x9" fmla="*/ 120 w 540"/>
-              <a:gd name="p0y9" fmla="*/ 540 h 540"/>
-              <a:gd name="p0x10" fmla="*/ 53 w 540"/>
-              <a:gd name="p0y10" fmla="*/ 540 h 540"/>
-              <a:gd name="p0x11" fmla="*/ 0 w 540"/>
-              <a:gd name="p0y11" fmla="*/ 486 h 540"/>
-              <a:gd name="p0x12" fmla="*/ 0 w 540"/>
-              <a:gd name="p0y12" fmla="*/ 420 h 540"/>
-              <a:gd name="p0x13" fmla="*/ 0 w 540"/>
-              <a:gd name="p0y13" fmla="*/ 120 h 540"/>
-              <a:gd name="p0x14" fmla="*/ 0 w 540"/>
-              <a:gd name="p0y14" fmla="*/ 53 h 540"/>
-              <a:gd name="p0x15" fmla="*/ 53 w 540"/>
-              <a:gd name="p0y15" fmla="*/ 0 h 540"/>
-              <a:gd name="p0x16" fmla="*/ 120 w 540"/>
-              <a:gd name="p0y16" fmla="*/ 0 h 540"/>
-            </a:gdLst>
-            <a:pathLst>
-              <a:path w="0" h="0">
-                <a:moveTo>
-                  <a:pt x="0" y="0"/>
-                </a:moveTo>
-                <a:lnTo>
-                  <a:pt x="0" y="0"/>
-                </a:lnTo>
-                <a:cubicBezTo>
-                  <a:pt x="0" y="0"/>
-                  <a:pt x="0" y="0"/>
-                  <a:pt x="0" y="0"/>
-                </a:cubicBezTo>
-                <a:lnTo>
-                  <a:pt x="0" y="0"/>
-                </a:lnTo>
-                <a:cubicBezTo>
-                  <a:pt x="0" y="0"/>
-                  <a:pt x="0" y="0"/>
-                  <a:pt x="0" y="0"/>
-                </a:cubicBezTo>
-                <a:lnTo>
-                  <a:pt x="0" y="0"/>
-                </a:lnTo>
-                <a:cubicBezTo>
-                  <a:pt x="0" y="0"/>
-                  <a:pt x="0" y="0"/>
-                  <a:pt x="0" y="0"/>
-                </a:cubicBezTo>
-                <a:lnTo>
-                  <a:pt x="0" y="0"/>
-                </a:lnTo>
-                <a:cubicBezTo>
-                  <a:pt x="0" y="0"/>
-                  <a:pt x="0" y="0"/>
-                  <a:pt x="0" y="0"/>
-                </a:cubicBezTo>
-                <a:close/>
-              </a:path>
-            </a:pathLst>
-          </a:custGeom>
-          <a:solidFill xmlns:a="http://schemas.openxmlformats.org/drawingml/2006/main">
-            <a:schemeClr val="accent1">
-              <a:alpha val="16078"/>
-            </a:schemeClr>
-          </a:solidFill>
-          <a:ln xmlns:a="http://schemas.openxmlformats.org/drawingml/2006/main">
-            <a:noFill/>
-          </a:ln>
-        </p:spPr>
-        <p:style>
-          <a:lnRef xmlns:a="http://schemas.openxmlformats.org/drawingml/2006/main" idx="2">
-            <a:schemeClr val="accent1">
-              <a:lumMod val="75000"/>
-            </a:schemeClr>
-          </a:lnRef>
-          <a:fillRef xmlns:a="http://schemas.openxmlformats.org/drawingml/2006/main" idx="1">
-            <a:schemeClr val="accent1"/>
-          </a:fillRef>
-          <a:effectRef xmlns:a="http://schemas.openxmlformats.org/drawingml/2006/main" idx="0">
-            <a:srgbClr val="FFFFFF"/>
-          </a:effectRef>
-          <a:fontRef xmlns:a="http://schemas.openxmlformats.org/drawingml/2006/main" idx="minor">
-            <a:schemeClr val="lt1"/>
-          </a:fontRef>
-        </p:style>
-        <p:txBody>
-          <a:bodyPr xmlns:a="http://schemas.openxmlformats.org/drawingml/2006/main" anchor="ctr"/>
-          <a:lstStyle xmlns:a="http://schemas.openxmlformats.org/drawingml/2006/main"/>
-          <a:p xmlns:a="http://schemas.openxmlformats.org/drawingml/2006/main">
-            <a:pPr algn="ctr">
-              <a:buNone/>
-            </a:pPr>
-            <a:endParaRPr/>
-          </a:p>
-        </p:txBody>
-      </p:sp>
-      <p:sp>
-        <p:nvSpPr>
-          <p:cNvPr id="29" name="文本框 28">
-            <a:extLst xmlns:a="http://schemas.openxmlformats.org/drawingml/2006/main">
-              <a:ext uri="{FF2B5EF4-FFF2-40B4-BE49-F238E27FC236}">
-                <a16:creationId xmlns:a16="http://schemas.microsoft.com/office/drawing/2014/main" id="{816A3E7F-9FF0-4DBD-B987-29154B96C591}"/>
-              </a:ext>
-            </a:extLst>
-          </p:cNvPr>
-          <p:cNvSpPr>
-            <a:spLocks xmlns:a="http://schemas.openxmlformats.org/drawingml/2006/main" noGrp="1"/>
-          </p:cNvSpPr>
-          <p:nvPr/>
-        </p:nvSpPr>
-        <p:spPr>
-          <a:xfrm xmlns:a="http://schemas.openxmlformats.org/drawingml/2006/main">
-            <a:off x="6450959" y="2759916"/>
-            <a:ext cx="471116" cy="239078"/>
-          </a:xfrm>
-          <a:prstGeom xmlns:a="http://schemas.openxmlformats.org/drawingml/2006/main" prst="rect">
-            <a:avLst/>
-          </a:prstGeom>
-          <a:noFill xmlns:a="http://schemas.openxmlformats.org/drawingml/2006/main"/>
-        </p:spPr>
-        <p:txBody>
-          <a:bodyPr xmlns:a="http://schemas.openxmlformats.org/drawingml/2006/main" wrap="square" lIns="0" tIns="0" rIns="0" bIns="0" anchor="t">
-            <a:noAutofit/>
-          </a:bodyPr>
-          <a:lstStyle xmlns:a="http://schemas.openxmlformats.org/drawingml/2006/main"/>
-          <a:p xmlns:a="http://schemas.openxmlformats.org/drawingml/2006/main">
-            <a:pPr algn="l">
-              <a:lnSpc>
-                <a:spcPct val="83000"/>
-              </a:lnSpc>
-              <a:buNone/>
-            </a:pPr>
-            <a:r>
-              <a:rPr sz="1650" b="1">
-                <a:solidFill>
-                  <a:srgbClr val="AF753D"/>
-                </a:solidFill>
-                <a:latin typeface="Microsoft YaHei"/>
-                <a:ea typeface="Microsoft YaHei"/>
-                <a:cs typeface="Microsoft YaHei"/>
-              </a:rPr>
-              <a:t>01</a:t>
-            </a:r>
-            <a:endParaRPr sz="1650" b="1">
-              <a:solidFill>
-                <a:srgbClr val="AF753D"/>
-              </a:solidFill>
-              <a:latin typeface="Microsoft YaHei"/>
-              <a:ea typeface="Microsoft YaHei"/>
-              <a:cs typeface="Microsoft YaHei"/>
-            </a:endParaRPr>
-          </a:p>
-        </p:txBody>
-      </p:sp>
-      <p:sp>
-        <p:nvSpPr>
-          <p:cNvPr id="30" name="文本框 29">
-            <a:extLst xmlns:a="http://schemas.openxmlformats.org/drawingml/2006/main">
-              <a:ext uri="{FF2B5EF4-FFF2-40B4-BE49-F238E27FC236}">
-                <a16:creationId xmlns:a16="http://schemas.microsoft.com/office/drawing/2014/main" id="{E41C8AB4-7480-4309-B091-50705565B3DF}"/>
-              </a:ext>
-            </a:extLst>
-          </p:cNvPr>
-          <p:cNvSpPr>
-            <a:spLocks xmlns:a="http://schemas.openxmlformats.org/drawingml/2006/main" noGrp="1"/>
-          </p:cNvSpPr>
-          <p:nvPr/>
-        </p:nvSpPr>
-        <p:spPr>
-          <a:xfrm xmlns:a="http://schemas.openxmlformats.org/drawingml/2006/main">
-            <a:off x="6867525" y="2748486"/>
-            <a:ext cx="3238500" cy="261938"/>
-          </a:xfrm>
-          <a:prstGeom xmlns:a="http://schemas.openxmlformats.org/drawingml/2006/main" prst="rect">
-            <a:avLst/>
-          </a:prstGeom>
-          <a:noFill xmlns:a="http://schemas.openxmlformats.org/drawingml/2006/main"/>
-        </p:spPr>
-        <p:txBody>
-          <a:bodyPr xmlns:a="http://schemas.openxmlformats.org/drawingml/2006/main" wrap="square" lIns="0" tIns="0" rIns="0" bIns="0" anchor="t">
-            <a:noAutofit/>
-          </a:bodyPr>
-          <a:lstStyle xmlns:a="http://schemas.openxmlformats.org/drawingml/2006/main"/>
-          <a:p xmlns:a="http://schemas.openxmlformats.org/drawingml/2006/main">
-            <a:pPr algn="l">
-              <a:lnSpc>
-                <a:spcPct val="104000"/>
-              </a:lnSpc>
-              <a:buNone/>
-            </a:pPr>
-            <a:r>
-              <a:rPr sz="1500" b="1">
-                <a:solidFill>
-                  <a:schemeClr val="tx2">
-                    <a:lumMod val="4356"/>
-                    <a:lumOff val="95644"/>
-                  </a:schemeClr>
-                </a:solidFill>
-                <a:latin typeface="Microsoft YaHei"/>
-                <a:ea typeface="Microsoft YaHei"/>
-                <a:cs typeface="Microsoft YaHei"/>
-              </a:rPr>
-              <a:t>识别｜品类、品牌、型号、属性</a:t>
-            </a:r>
-            <a:endParaRPr sz="1500" b="1">
-              <a:solidFill>
-                <a:schemeClr val="tx2">
-                  <a:lumMod val="4356"/>
-                  <a:lumOff val="95644"/>
-                </a:schemeClr>
-              </a:solidFill>
-              <a:latin typeface="Microsoft YaHei"/>
-              <a:ea typeface="Microsoft YaHei"/>
-              <a:cs typeface="Microsoft YaHei"/>
-            </a:endParaRPr>
-          </a:p>
-        </p:txBody>
-      </p:sp>
-      <p:sp>
-        <p:nvSpPr>
-          <p:cNvPr id="31" name="任意多边形 30">
-            <a:extLst xmlns:a="http://schemas.openxmlformats.org/drawingml/2006/main">
-              <a:ext uri="{FF2B5EF4-FFF2-40B4-BE49-F238E27FC236}">
-                <a16:creationId xmlns:a16="http://schemas.microsoft.com/office/drawing/2014/main" id="{5508DF17-305C-44F6-A857-4357E2C8DE4D}"/>
-              </a:ext>
-            </a:extLst>
-          </p:cNvPr>
-          <p:cNvSpPr>
-            <a:spLocks xmlns:a="http://schemas.openxmlformats.org/drawingml/2006/main" noGrp="1"/>
-          </p:cNvSpPr>
-          <p:nvPr/>
-        </p:nvSpPr>
-        <p:spPr>
-          <a:xfrm xmlns:a="http://schemas.openxmlformats.org/drawingml/2006/main">
-            <a:off x="6410325" y="3157220"/>
-            <a:ext cx="342900" cy="342900"/>
-          </a:xfrm>
-          <a:custGeom xmlns:a="http://schemas.openxmlformats.org/drawingml/2006/main">
-            <a:gdLst>
-              <a:gd name="sw" fmla="*/ 1 w 540"/>
-              <a:gd name="sh" fmla="*/ 1 h 540"/>
-              <a:gd name="mins" fmla="min sw sh"/>
-              <a:gd name="dsw" fmla="+- 0 sw mins"/>
-              <a:gd name="dsh" fmla="+- 0 sh mins"/>
-              <a:gd name="p0x0" fmla="*/ 120 w 540"/>
-              <a:gd name="p0y0" fmla="*/ 0 h 540"/>
-              <a:gd name="p0x1" fmla="*/ 420 w 540"/>
-              <a:gd name="p0y1" fmla="*/ 0 h 540"/>
-              <a:gd name="p0x2" fmla="*/ 486 w 540"/>
-              <a:gd name="p0y2" fmla="*/ 0 h 540"/>
-              <a:gd name="p0x3" fmla="*/ 540 w 540"/>
-              <a:gd name="p0y3" fmla="*/ 53 h 540"/>
-              <a:gd name="p0x4" fmla="*/ 540 w 540"/>
-              <a:gd name="p0y4" fmla="*/ 120 h 540"/>
-              <a:gd name="p0x5" fmla="*/ 540 w 540"/>
-              <a:gd name="p0y5" fmla="*/ 420 h 540"/>
-              <a:gd name="p0x6" fmla="*/ 540 w 540"/>
-              <a:gd name="p0y6" fmla="*/ 486 h 540"/>
-              <a:gd name="p0x7" fmla="*/ 486 w 540"/>
-              <a:gd name="p0y7" fmla="*/ 540 h 540"/>
-              <a:gd name="p0x8" fmla="*/ 420 w 540"/>
-              <a:gd name="p0y8" fmla="*/ 540 h 540"/>
-              <a:gd name="p0x9" fmla="*/ 120 w 540"/>
-              <a:gd name="p0y9" fmla="*/ 540 h 540"/>
-              <a:gd name="p0x10" fmla="*/ 53 w 540"/>
-              <a:gd name="p0y10" fmla="*/ 540 h 540"/>
-              <a:gd name="p0x11" fmla="*/ 0 w 540"/>
-              <a:gd name="p0y11" fmla="*/ 486 h 540"/>
-              <a:gd name="p0x12" fmla="*/ 0 w 540"/>
-              <a:gd name="p0y12" fmla="*/ 420 h 540"/>
-              <a:gd name="p0x13" fmla="*/ 0 w 540"/>
-              <a:gd name="p0y13" fmla="*/ 120 h 540"/>
-              <a:gd name="p0x14" fmla="*/ 0 w 540"/>
-              <a:gd name="p0y14" fmla="*/ 53 h 540"/>
-              <a:gd name="p0x15" fmla="*/ 53 w 540"/>
-              <a:gd name="p0y15" fmla="*/ 0 h 540"/>
-              <a:gd name="p0x16" fmla="*/ 120 w 540"/>
-              <a:gd name="p0y16" fmla="*/ 0 h 540"/>
-            </a:gdLst>
-            <a:pathLst>
-              <a:path w="0" h="0">
-                <a:moveTo>
-                  <a:pt x="0" y="0"/>
-                </a:moveTo>
-                <a:lnTo>
-                  <a:pt x="0" y="0"/>
-                </a:lnTo>
-                <a:cubicBezTo>
-                  <a:pt x="0" y="0"/>
-                  <a:pt x="0" y="0"/>
-                  <a:pt x="0" y="0"/>
-                </a:cubicBezTo>
-                <a:lnTo>
-                  <a:pt x="0" y="0"/>
-                </a:lnTo>
-                <a:cubicBezTo>
-                  <a:pt x="0" y="0"/>
-                  <a:pt x="0" y="0"/>
-                  <a:pt x="0" y="0"/>
-                </a:cubicBezTo>
-                <a:lnTo>
-                  <a:pt x="0" y="0"/>
-                </a:lnTo>
-                <a:cubicBezTo>
-                  <a:pt x="0" y="0"/>
-                  <a:pt x="0" y="0"/>
-                  <a:pt x="0" y="0"/>
-                </a:cubicBezTo>
-                <a:lnTo>
-                  <a:pt x="0" y="0"/>
-                </a:lnTo>
-                <a:cubicBezTo>
-                  <a:pt x="0" y="0"/>
-                  <a:pt x="0" y="0"/>
-                  <a:pt x="0" y="0"/>
-                </a:cubicBezTo>
-                <a:close/>
-              </a:path>
-            </a:pathLst>
-          </a:custGeom>
-          <a:solidFill xmlns:a="http://schemas.openxmlformats.org/drawingml/2006/main">
-            <a:schemeClr val="accent1">
-              <a:alpha val="16078"/>
-            </a:schemeClr>
-          </a:solidFill>
-          <a:ln xmlns:a="http://schemas.openxmlformats.org/drawingml/2006/main">
-            <a:noFill/>
-          </a:ln>
-        </p:spPr>
-        <p:style>
-          <a:lnRef xmlns:a="http://schemas.openxmlformats.org/drawingml/2006/main" idx="2">
-            <a:schemeClr val="accent1">
-              <a:lumMod val="75000"/>
-            </a:schemeClr>
-          </a:lnRef>
-          <a:fillRef xmlns:a="http://schemas.openxmlformats.org/drawingml/2006/main" idx="1">
-            <a:schemeClr val="accent1"/>
-          </a:fillRef>
-          <a:effectRef xmlns:a="http://schemas.openxmlformats.org/drawingml/2006/main" idx="0">
-            <a:srgbClr val="FFFFFF"/>
-          </a:effectRef>
-          <a:fontRef xmlns:a="http://schemas.openxmlformats.org/drawingml/2006/main" idx="minor">
-            <a:schemeClr val="lt1"/>
-          </a:fontRef>
-        </p:style>
-        <p:txBody>
-          <a:bodyPr xmlns:a="http://schemas.openxmlformats.org/drawingml/2006/main" anchor="ctr"/>
-          <a:lstStyle xmlns:a="http://schemas.openxmlformats.org/drawingml/2006/main"/>
-          <a:p xmlns:a="http://schemas.openxmlformats.org/drawingml/2006/main">
-            <a:pPr algn="ctr">
-              <a:buNone/>
-            </a:pPr>
-            <a:endParaRPr/>
-          </a:p>
-        </p:txBody>
-      </p:sp>
-      <p:sp>
-        <p:nvSpPr>
-          <p:cNvPr id="32" name="文本框 31">
-            <a:extLst xmlns:a="http://schemas.openxmlformats.org/drawingml/2006/main">
-              <a:ext uri="{FF2B5EF4-FFF2-40B4-BE49-F238E27FC236}">
-                <a16:creationId xmlns:a16="http://schemas.microsoft.com/office/drawing/2014/main" id="{A7F923C1-6FAF-4CCA-86A1-E65A91DB0364}"/>
-              </a:ext>
-            </a:extLst>
-          </p:cNvPr>
-          <p:cNvSpPr>
-            <a:spLocks xmlns:a="http://schemas.openxmlformats.org/drawingml/2006/main" noGrp="1"/>
-          </p:cNvSpPr>
-          <p:nvPr/>
-        </p:nvSpPr>
-        <p:spPr>
-          <a:xfrm xmlns:a="http://schemas.openxmlformats.org/drawingml/2006/main">
-            <a:off x="6450959" y="3207220"/>
-            <a:ext cx="471116" cy="239078"/>
-          </a:xfrm>
-          <a:prstGeom xmlns:a="http://schemas.openxmlformats.org/drawingml/2006/main" prst="rect">
-            <a:avLst/>
-          </a:prstGeom>
-          <a:noFill xmlns:a="http://schemas.openxmlformats.org/drawingml/2006/main"/>
-        </p:spPr>
-        <p:txBody>
-          <a:bodyPr xmlns:a="http://schemas.openxmlformats.org/drawingml/2006/main" wrap="square" lIns="0" tIns="0" rIns="0" bIns="0" anchor="t">
-            <a:noAutofit/>
-          </a:bodyPr>
-          <a:lstStyle xmlns:a="http://schemas.openxmlformats.org/drawingml/2006/main"/>
-          <a:p xmlns:a="http://schemas.openxmlformats.org/drawingml/2006/main">
-            <a:pPr algn="l">
-              <a:lnSpc>
-                <a:spcPct val="83000"/>
-              </a:lnSpc>
-              <a:buNone/>
-            </a:pPr>
-            <a:r>
-              <a:rPr sz="1650" b="1">
-                <a:solidFill>
-                  <a:srgbClr val="AF753D"/>
-                </a:solidFill>
-                <a:latin typeface="Microsoft YaHei"/>
-                <a:ea typeface="Microsoft YaHei"/>
-                <a:cs typeface="Microsoft YaHei"/>
-              </a:rPr>
-              <a:t>02</a:t>
-            </a:r>
-            <a:endParaRPr sz="1650" b="1">
-              <a:solidFill>
-                <a:srgbClr val="AF753D"/>
-              </a:solidFill>
-              <a:latin typeface="Microsoft YaHei"/>
-              <a:ea typeface="Microsoft YaHei"/>
-              <a:cs typeface="Microsoft YaHei"/>
-            </a:endParaRPr>
-          </a:p>
-        </p:txBody>
-      </p:sp>
-      <p:sp>
-        <p:nvSpPr>
-          <p:cNvPr id="33" name="文本框 32">
-            <a:extLst xmlns:a="http://schemas.openxmlformats.org/drawingml/2006/main">
-              <a:ext uri="{FF2B5EF4-FFF2-40B4-BE49-F238E27FC236}">
-                <a16:creationId xmlns:a16="http://schemas.microsoft.com/office/drawing/2014/main" id="{1ADB846A-AD60-4C11-A2D4-F3A012B91590}"/>
-              </a:ext>
-            </a:extLst>
-          </p:cNvPr>
-          <p:cNvSpPr>
-            <a:spLocks xmlns:a="http://schemas.openxmlformats.org/drawingml/2006/main" noGrp="1"/>
-          </p:cNvSpPr>
-          <p:nvPr/>
-        </p:nvSpPr>
-        <p:spPr>
-          <a:xfrm xmlns:a="http://schemas.openxmlformats.org/drawingml/2006/main">
-            <a:off x="6867525" y="3195790"/>
-            <a:ext cx="3671735" cy="261938"/>
-          </a:xfrm>
-          <a:prstGeom xmlns:a="http://schemas.openxmlformats.org/drawingml/2006/main" prst="rect">
-            <a:avLst/>
-          </a:prstGeom>
-          <a:noFill xmlns:a="http://schemas.openxmlformats.org/drawingml/2006/main"/>
-        </p:spPr>
-        <p:txBody>
-          <a:bodyPr xmlns:a="http://schemas.openxmlformats.org/drawingml/2006/main" wrap="square" lIns="0" tIns="0" rIns="0" bIns="0" anchor="t">
-            <a:noAutofit/>
-          </a:bodyPr>
-          <a:lstStyle xmlns:a="http://schemas.openxmlformats.org/drawingml/2006/main"/>
-          <a:p xmlns:a="http://schemas.openxmlformats.org/drawingml/2006/main">
-            <a:pPr algn="l">
-              <a:lnSpc>
-                <a:spcPct val="104000"/>
-              </a:lnSpc>
-              <a:buNone/>
-            </a:pPr>
-            <a:r>
-              <a:rPr sz="1500" b="1">
-                <a:solidFill>
-                  <a:schemeClr val="tx2">
-                    <a:lumMod val="4356"/>
-                    <a:lumOff val="95644"/>
-                  </a:schemeClr>
-                </a:solidFill>
-                <a:latin typeface="Microsoft YaHei"/>
-                <a:ea typeface="Microsoft YaHei"/>
-                <a:cs typeface="Microsoft YaHei"/>
-              </a:rPr>
-              <a:t>约束｜合并预算、平台、颜色等条件</a:t>
-            </a:r>
-            <a:endParaRPr sz="1500" b="1">
-              <a:solidFill>
-                <a:schemeClr val="tx2">
-                  <a:lumMod val="4356"/>
-                  <a:lumOff val="95644"/>
-                </a:schemeClr>
-              </a:solidFill>
-              <a:latin typeface="Microsoft YaHei"/>
-              <a:ea typeface="Microsoft YaHei"/>
-              <a:cs typeface="Microsoft YaHei"/>
-            </a:endParaRPr>
-          </a:p>
-        </p:txBody>
-      </p:sp>
-      <p:sp>
-        <p:nvSpPr>
-          <p:cNvPr id="34" name="任意多边形 33">
-            <a:extLst xmlns:a="http://schemas.openxmlformats.org/drawingml/2006/main">
-              <a:ext uri="{FF2B5EF4-FFF2-40B4-BE49-F238E27FC236}">
-                <a16:creationId xmlns:a16="http://schemas.microsoft.com/office/drawing/2014/main" id="{43B2D0CE-E8DB-472C-A9E7-3CAE8C8AAC29}"/>
-              </a:ext>
-            </a:extLst>
-          </p:cNvPr>
-          <p:cNvSpPr>
-            <a:spLocks xmlns:a="http://schemas.openxmlformats.org/drawingml/2006/main" noGrp="1"/>
-          </p:cNvSpPr>
-          <p:nvPr/>
-        </p:nvSpPr>
-        <p:spPr>
-          <a:xfrm xmlns:a="http://schemas.openxmlformats.org/drawingml/2006/main">
-            <a:off x="6410325" y="3604895"/>
-            <a:ext cx="342900" cy="342900"/>
-          </a:xfrm>
-          <a:custGeom xmlns:a="http://schemas.openxmlformats.org/drawingml/2006/main">
-            <a:gdLst>
-              <a:gd name="sw" fmla="*/ 1 w 540"/>
-              <a:gd name="sh" fmla="*/ 1 h 540"/>
-              <a:gd name="mins" fmla="min sw sh"/>
-              <a:gd name="dsw" fmla="+- 0 sw mins"/>
-              <a:gd name="dsh" fmla="+- 0 sh mins"/>
-              <a:gd name="p0x0" fmla="*/ 120 w 540"/>
-              <a:gd name="p0y0" fmla="*/ 0 h 540"/>
-              <a:gd name="p0x1" fmla="*/ 420 w 540"/>
-              <a:gd name="p0y1" fmla="*/ 0 h 540"/>
-              <a:gd name="p0x2" fmla="*/ 486 w 540"/>
-              <a:gd name="p0y2" fmla="*/ 0 h 540"/>
-              <a:gd name="p0x3" fmla="*/ 540 w 540"/>
-              <a:gd name="p0y3" fmla="*/ 53 h 540"/>
-              <a:gd name="p0x4" fmla="*/ 540 w 540"/>
-              <a:gd name="p0y4" fmla="*/ 120 h 540"/>
-              <a:gd name="p0x5" fmla="*/ 540 w 540"/>
-              <a:gd name="p0y5" fmla="*/ 420 h 540"/>
-              <a:gd name="p0x6" fmla="*/ 540 w 540"/>
-              <a:gd name="p0y6" fmla="*/ 486 h 540"/>
-              <a:gd name="p0x7" fmla="*/ 486 w 540"/>
-              <a:gd name="p0y7" fmla="*/ 540 h 540"/>
-              <a:gd name="p0x8" fmla="*/ 420 w 540"/>
-              <a:gd name="p0y8" fmla="*/ 540 h 540"/>
-              <a:gd name="p0x9" fmla="*/ 120 w 540"/>
-              <a:gd name="p0y9" fmla="*/ 540 h 540"/>
-              <a:gd name="p0x10" fmla="*/ 53 w 540"/>
-              <a:gd name="p0y10" fmla="*/ 540 h 540"/>
-              <a:gd name="p0x11" fmla="*/ 0 w 540"/>
-              <a:gd name="p0y11" fmla="*/ 486 h 540"/>
-              <a:gd name="p0x12" fmla="*/ 0 w 540"/>
-              <a:gd name="p0y12" fmla="*/ 420 h 540"/>
-              <a:gd name="p0x13" fmla="*/ 0 w 540"/>
-              <a:gd name="p0y13" fmla="*/ 120 h 540"/>
-              <a:gd name="p0x14" fmla="*/ 0 w 540"/>
-              <a:gd name="p0y14" fmla="*/ 53 h 540"/>
-              <a:gd name="p0x15" fmla="*/ 53 w 540"/>
-              <a:gd name="p0y15" fmla="*/ 0 h 540"/>
-              <a:gd name="p0x16" fmla="*/ 120 w 540"/>
-              <a:gd name="p0y16" fmla="*/ 0 h 540"/>
-            </a:gdLst>
-            <a:pathLst>
-              <a:path w="0" h="0">
-                <a:moveTo>
-                  <a:pt x="0" y="0"/>
-                </a:moveTo>
-                <a:lnTo>
-                  <a:pt x="0" y="0"/>
-                </a:lnTo>
-                <a:cubicBezTo>
-                  <a:pt x="0" y="0"/>
-                  <a:pt x="0" y="0"/>
-                  <a:pt x="0" y="0"/>
-                </a:cubicBezTo>
-                <a:lnTo>
-                  <a:pt x="0" y="0"/>
-                </a:lnTo>
-                <a:cubicBezTo>
-                  <a:pt x="0" y="0"/>
-                  <a:pt x="0" y="0"/>
-                  <a:pt x="0" y="0"/>
-                </a:cubicBezTo>
-                <a:lnTo>
-                  <a:pt x="0" y="0"/>
-                </a:lnTo>
-                <a:cubicBezTo>
-                  <a:pt x="0" y="0"/>
-                  <a:pt x="0" y="0"/>
-                  <a:pt x="0" y="0"/>
-                </a:cubicBezTo>
-                <a:lnTo>
-                  <a:pt x="0" y="0"/>
-                </a:lnTo>
-                <a:cubicBezTo>
-                  <a:pt x="0" y="0"/>
-                  <a:pt x="0" y="0"/>
-                  <a:pt x="0" y="0"/>
-                </a:cubicBezTo>
-                <a:close/>
-              </a:path>
-            </a:pathLst>
-          </a:custGeom>
-          <a:solidFill xmlns:a="http://schemas.openxmlformats.org/drawingml/2006/main">
-            <a:schemeClr val="accent1">
-              <a:alpha val="16078"/>
-            </a:schemeClr>
-          </a:solidFill>
-          <a:ln xmlns:a="http://schemas.openxmlformats.org/drawingml/2006/main">
-            <a:noFill/>
-          </a:ln>
-        </p:spPr>
-        <p:style>
-          <a:lnRef xmlns:a="http://schemas.openxmlformats.org/drawingml/2006/main" idx="2">
-            <a:schemeClr val="accent1">
-              <a:lumMod val="75000"/>
-            </a:schemeClr>
-          </a:lnRef>
-          <a:fillRef xmlns:a="http://schemas.openxmlformats.org/drawingml/2006/main" idx="1">
-            <a:schemeClr val="accent1"/>
-          </a:fillRef>
-          <a:effectRef xmlns:a="http://schemas.openxmlformats.org/drawingml/2006/main" idx="0">
-            <a:srgbClr val="FFFFFF"/>
-          </a:effectRef>
-          <a:fontRef xmlns:a="http://schemas.openxmlformats.org/drawingml/2006/main" idx="minor">
-            <a:schemeClr val="lt1"/>
-          </a:fontRef>
-        </p:style>
-        <p:txBody>
-          <a:bodyPr xmlns:a="http://schemas.openxmlformats.org/drawingml/2006/main" anchor="ctr"/>
-          <a:lstStyle xmlns:a="http://schemas.openxmlformats.org/drawingml/2006/main"/>
-          <a:p xmlns:a="http://schemas.openxmlformats.org/drawingml/2006/main">
-            <a:pPr algn="ctr">
-              <a:buNone/>
-            </a:pPr>
-            <a:endParaRPr/>
-          </a:p>
-        </p:txBody>
-      </p:sp>
-      <p:sp>
-        <p:nvSpPr>
-          <p:cNvPr id="35" name="文本框 34">
-            <a:extLst xmlns:a="http://schemas.openxmlformats.org/drawingml/2006/main">
-              <a:ext uri="{FF2B5EF4-FFF2-40B4-BE49-F238E27FC236}">
-                <a16:creationId xmlns:a16="http://schemas.microsoft.com/office/drawing/2014/main" id="{B88B57AA-3D06-425D-8BDA-626CE3FF8565}"/>
-              </a:ext>
-            </a:extLst>
-          </p:cNvPr>
-          <p:cNvSpPr>
-            <a:spLocks xmlns:a="http://schemas.openxmlformats.org/drawingml/2006/main" noGrp="1"/>
-          </p:cNvSpPr>
-          <p:nvPr/>
-        </p:nvSpPr>
-        <p:spPr>
-          <a:xfrm xmlns:a="http://schemas.openxmlformats.org/drawingml/2006/main">
-            <a:off x="6450959" y="3654523"/>
-            <a:ext cx="471116" cy="239078"/>
-          </a:xfrm>
-          <a:prstGeom xmlns:a="http://schemas.openxmlformats.org/drawingml/2006/main" prst="rect">
-            <a:avLst/>
-          </a:prstGeom>
-          <a:noFill xmlns:a="http://schemas.openxmlformats.org/drawingml/2006/main"/>
-        </p:spPr>
-        <p:txBody>
-          <a:bodyPr xmlns:a="http://schemas.openxmlformats.org/drawingml/2006/main" wrap="square" lIns="0" tIns="0" rIns="0" bIns="0" anchor="t">
-            <a:noAutofit/>
-          </a:bodyPr>
-          <a:lstStyle xmlns:a="http://schemas.openxmlformats.org/drawingml/2006/main"/>
-          <a:p xmlns:a="http://schemas.openxmlformats.org/drawingml/2006/main">
-            <a:pPr algn="l">
-              <a:lnSpc>
-                <a:spcPct val="83000"/>
-              </a:lnSpc>
-              <a:buNone/>
-            </a:pPr>
-            <a:r>
-              <a:rPr sz="1650" b="1">
-                <a:solidFill>
-                  <a:srgbClr val="AF753D"/>
-                </a:solidFill>
-                <a:latin typeface="Microsoft YaHei"/>
-                <a:ea typeface="Microsoft YaHei"/>
-                <a:cs typeface="Microsoft YaHei"/>
-              </a:rPr>
-              <a:t>03</a:t>
-            </a:r>
-            <a:endParaRPr sz="1650" b="1">
-              <a:solidFill>
-                <a:srgbClr val="AF753D"/>
-              </a:solidFill>
-              <a:latin typeface="Microsoft YaHei"/>
-              <a:ea typeface="Microsoft YaHei"/>
-              <a:cs typeface="Microsoft YaHei"/>
-            </a:endParaRPr>
-          </a:p>
-        </p:txBody>
-      </p:sp>
-      <p:sp>
-        <p:nvSpPr>
-          <p:cNvPr id="36" name="文本框 35">
-            <a:extLst xmlns:a="http://schemas.openxmlformats.org/drawingml/2006/main">
-              <a:ext uri="{FF2B5EF4-FFF2-40B4-BE49-F238E27FC236}">
-                <a16:creationId xmlns:a16="http://schemas.microsoft.com/office/drawing/2014/main" id="{31B87B5F-0FAD-4423-9F9F-C907CFAF5C65}"/>
-              </a:ext>
-            </a:extLst>
-          </p:cNvPr>
-          <p:cNvSpPr>
-            <a:spLocks xmlns:a="http://schemas.openxmlformats.org/drawingml/2006/main" noGrp="1"/>
-          </p:cNvSpPr>
-          <p:nvPr/>
-        </p:nvSpPr>
-        <p:spPr>
-          <a:xfrm xmlns:a="http://schemas.openxmlformats.org/drawingml/2006/main">
-            <a:off x="6867525" y="3643094"/>
-            <a:ext cx="3438744" cy="261938"/>
-          </a:xfrm>
-          <a:prstGeom xmlns:a="http://schemas.openxmlformats.org/drawingml/2006/main" prst="rect">
-            <a:avLst/>
-          </a:prstGeom>
-          <a:noFill xmlns:a="http://schemas.openxmlformats.org/drawingml/2006/main"/>
-        </p:spPr>
-        <p:txBody>
-          <a:bodyPr xmlns:a="http://schemas.openxmlformats.org/drawingml/2006/main" wrap="square" lIns="0" tIns="0" rIns="0" bIns="0" anchor="t">
-            <a:noAutofit/>
-          </a:bodyPr>
-          <a:lstStyle xmlns:a="http://schemas.openxmlformats.org/drawingml/2006/main"/>
-          <a:p xmlns:a="http://schemas.openxmlformats.org/drawingml/2006/main">
-            <a:pPr algn="l">
-              <a:lnSpc>
-                <a:spcPct val="104000"/>
-              </a:lnSpc>
-              <a:buNone/>
-            </a:pPr>
-            <a:r>
-              <a:rPr sz="1500" b="1">
-                <a:solidFill>
-                  <a:schemeClr val="tx2">
-                    <a:lumMod val="4356"/>
-                    <a:lumOff val="95644"/>
-                  </a:schemeClr>
-                </a:solidFill>
-                <a:latin typeface="Microsoft YaHei"/>
-                <a:ea typeface="Microsoft YaHei"/>
-                <a:cs typeface="Microsoft YaHei"/>
-              </a:rPr>
-              <a:t>检索｜混合召回、同款判定、SKU 拆分</a:t>
-            </a:r>
-            <a:endParaRPr sz="1500" b="1">
-              <a:solidFill>
-                <a:schemeClr val="tx2">
-                  <a:lumMod val="4356"/>
-                  <a:lumOff val="95644"/>
-                </a:schemeClr>
-              </a:solidFill>
-              <a:latin typeface="Microsoft YaHei"/>
-              <a:ea typeface="Microsoft YaHei"/>
-              <a:cs typeface="Microsoft YaHei"/>
-            </a:endParaRPr>
-          </a:p>
-        </p:txBody>
-      </p:sp>
-      <p:sp>
-        <p:nvSpPr>
-          <p:cNvPr id="37" name="任意多边形 36">
-            <a:extLst xmlns:a="http://schemas.openxmlformats.org/drawingml/2006/main">
-              <a:ext uri="{FF2B5EF4-FFF2-40B4-BE49-F238E27FC236}">
-                <a16:creationId xmlns:a16="http://schemas.microsoft.com/office/drawing/2014/main" id="{766C214A-E0EC-4E65-BEF9-3923D5323C45}"/>
-              </a:ext>
-            </a:extLst>
-          </p:cNvPr>
-          <p:cNvSpPr>
-            <a:spLocks xmlns:a="http://schemas.openxmlformats.org/drawingml/2006/main" noGrp="1"/>
-          </p:cNvSpPr>
-          <p:nvPr/>
-        </p:nvSpPr>
-        <p:spPr>
-          <a:xfrm xmlns:a="http://schemas.openxmlformats.org/drawingml/2006/main">
-            <a:off x="6410325" y="4051935"/>
-            <a:ext cx="342900" cy="342900"/>
-          </a:xfrm>
-          <a:custGeom xmlns:a="http://schemas.openxmlformats.org/drawingml/2006/main">
-            <a:gdLst>
-              <a:gd name="sw" fmla="*/ 1 w 540"/>
-              <a:gd name="sh" fmla="*/ 1 h 540"/>
-              <a:gd name="mins" fmla="min sw sh"/>
-              <a:gd name="dsw" fmla="+- 0 sw mins"/>
-              <a:gd name="dsh" fmla="+- 0 sh mins"/>
-              <a:gd name="p0x0" fmla="*/ 120 w 540"/>
-              <a:gd name="p0y0" fmla="*/ 0 h 540"/>
-              <a:gd name="p0x1" fmla="*/ 420 w 540"/>
-              <a:gd name="p0y1" fmla="*/ 0 h 540"/>
-              <a:gd name="p0x2" fmla="*/ 486 w 540"/>
-              <a:gd name="p0y2" fmla="*/ 0 h 540"/>
-              <a:gd name="p0x3" fmla="*/ 540 w 540"/>
-              <a:gd name="p0y3" fmla="*/ 53 h 540"/>
-              <a:gd name="p0x4" fmla="*/ 540 w 540"/>
-              <a:gd name="p0y4" fmla="*/ 120 h 540"/>
-              <a:gd name="p0x5" fmla="*/ 540 w 540"/>
-              <a:gd name="p0y5" fmla="*/ 420 h 540"/>
-              <a:gd name="p0x6" fmla="*/ 540 w 540"/>
-              <a:gd name="p0y6" fmla="*/ 486 h 540"/>
-              <a:gd name="p0x7" fmla="*/ 486 w 540"/>
-              <a:gd name="p0y7" fmla="*/ 540 h 540"/>
-              <a:gd name="p0x8" fmla="*/ 420 w 540"/>
-              <a:gd name="p0y8" fmla="*/ 540 h 540"/>
-              <a:gd name="p0x9" fmla="*/ 120 w 540"/>
-              <a:gd name="p0y9" fmla="*/ 540 h 540"/>
-              <a:gd name="p0x10" fmla="*/ 53 w 540"/>
-              <a:gd name="p0y10" fmla="*/ 540 h 540"/>
-              <a:gd name="p0x11" fmla="*/ 0 w 540"/>
-              <a:gd name="p0y11" fmla="*/ 486 h 540"/>
-              <a:gd name="p0x12" fmla="*/ 0 w 540"/>
-              <a:gd name="p0y12" fmla="*/ 420 h 540"/>
-              <a:gd name="p0x13" fmla="*/ 0 w 540"/>
-              <a:gd name="p0y13" fmla="*/ 120 h 540"/>
-              <a:gd name="p0x14" fmla="*/ 0 w 540"/>
-              <a:gd name="p0y14" fmla="*/ 53 h 540"/>
-              <a:gd name="p0x15" fmla="*/ 53 w 540"/>
-              <a:gd name="p0y15" fmla="*/ 0 h 540"/>
-              <a:gd name="p0x16" fmla="*/ 120 w 540"/>
-              <a:gd name="p0y16" fmla="*/ 0 h 540"/>
-            </a:gdLst>
-            <a:pathLst>
-              <a:path w="0" h="0">
-                <a:moveTo>
-                  <a:pt x="0" y="0"/>
-                </a:moveTo>
-                <a:lnTo>
-                  <a:pt x="0" y="0"/>
-                </a:lnTo>
-                <a:cubicBezTo>
-                  <a:pt x="0" y="0"/>
-                  <a:pt x="0" y="0"/>
-                  <a:pt x="0" y="0"/>
-                </a:cubicBezTo>
-                <a:lnTo>
-                  <a:pt x="0" y="0"/>
-                </a:lnTo>
-                <a:cubicBezTo>
-                  <a:pt x="0" y="0"/>
-                  <a:pt x="0" y="0"/>
-                  <a:pt x="0" y="0"/>
-                </a:cubicBezTo>
-                <a:lnTo>
-                  <a:pt x="0" y="0"/>
-                </a:lnTo>
-                <a:cubicBezTo>
-                  <a:pt x="0" y="0"/>
-                  <a:pt x="0" y="0"/>
-                  <a:pt x="0" y="0"/>
-                </a:cubicBezTo>
-                <a:lnTo>
-                  <a:pt x="0" y="0"/>
-                </a:lnTo>
-                <a:cubicBezTo>
-                  <a:pt x="0" y="0"/>
-                  <a:pt x="0" y="0"/>
-                  <a:pt x="0" y="0"/>
-                </a:cubicBezTo>
-                <a:close/>
-              </a:path>
-            </a:pathLst>
-          </a:custGeom>
-          <a:solidFill xmlns:a="http://schemas.openxmlformats.org/drawingml/2006/main">
-            <a:schemeClr val="accent1">
-              <a:alpha val="16078"/>
-            </a:schemeClr>
-          </a:solidFill>
-          <a:ln xmlns:a="http://schemas.openxmlformats.org/drawingml/2006/main">
-            <a:noFill/>
-          </a:ln>
-        </p:spPr>
-        <p:style>
-          <a:lnRef xmlns:a="http://schemas.openxmlformats.org/drawingml/2006/main" idx="2">
-            <a:schemeClr val="accent1">
-              <a:lumMod val="75000"/>
-            </a:schemeClr>
-          </a:lnRef>
-          <a:fillRef xmlns:a="http://schemas.openxmlformats.org/drawingml/2006/main" idx="1">
-            <a:schemeClr val="accent1"/>
-          </a:fillRef>
-          <a:effectRef xmlns:a="http://schemas.openxmlformats.org/drawingml/2006/main" idx="0">
-            <a:srgbClr val="FFFFFF"/>
-          </a:effectRef>
-          <a:fontRef xmlns:a="http://schemas.openxmlformats.org/drawingml/2006/main" idx="minor">
-            <a:schemeClr val="lt1"/>
-          </a:fontRef>
-        </p:style>
-        <p:txBody>
-          <a:bodyPr xmlns:a="http://schemas.openxmlformats.org/drawingml/2006/main" anchor="ctr"/>
-          <a:lstStyle xmlns:a="http://schemas.openxmlformats.org/drawingml/2006/main"/>
-          <a:p xmlns:a="http://schemas.openxmlformats.org/drawingml/2006/main">
-            <a:pPr algn="ctr">
-              <a:buNone/>
-            </a:pPr>
-            <a:endParaRPr/>
-          </a:p>
-        </p:txBody>
-      </p:sp>
-      <p:sp>
-        <p:nvSpPr>
-          <p:cNvPr id="38" name="文本框 37">
-            <a:extLst xmlns:a="http://schemas.openxmlformats.org/drawingml/2006/main">
-              <a:ext uri="{FF2B5EF4-FFF2-40B4-BE49-F238E27FC236}">
-                <a16:creationId xmlns:a16="http://schemas.microsoft.com/office/drawing/2014/main" id="{3ACDFD96-E404-4854-BC75-F7F255CEB905}"/>
-              </a:ext>
-            </a:extLst>
-          </p:cNvPr>
-          <p:cNvSpPr>
-            <a:spLocks xmlns:a="http://schemas.openxmlformats.org/drawingml/2006/main" noGrp="1"/>
-          </p:cNvSpPr>
-          <p:nvPr/>
-        </p:nvSpPr>
-        <p:spPr>
-          <a:xfrm xmlns:a="http://schemas.openxmlformats.org/drawingml/2006/main">
-            <a:off x="6450959" y="4101827"/>
-            <a:ext cx="471116" cy="239078"/>
-          </a:xfrm>
-          <a:prstGeom xmlns:a="http://schemas.openxmlformats.org/drawingml/2006/main" prst="rect">
-            <a:avLst/>
-          </a:prstGeom>
-          <a:noFill xmlns:a="http://schemas.openxmlformats.org/drawingml/2006/main"/>
-        </p:spPr>
-        <p:txBody>
-          <a:bodyPr xmlns:a="http://schemas.openxmlformats.org/drawingml/2006/main" wrap="square" lIns="0" tIns="0" rIns="0" bIns="0" anchor="t">
-            <a:noAutofit/>
-          </a:bodyPr>
-          <a:lstStyle xmlns:a="http://schemas.openxmlformats.org/drawingml/2006/main"/>
-          <a:p xmlns:a="http://schemas.openxmlformats.org/drawingml/2006/main">
-            <a:pPr algn="l">
-              <a:lnSpc>
-                <a:spcPct val="83000"/>
-              </a:lnSpc>
-              <a:buNone/>
-            </a:pPr>
-            <a:r>
-              <a:rPr sz="1650" b="1">
-                <a:solidFill>
-                  <a:srgbClr val="AF753D"/>
-                </a:solidFill>
-                <a:latin typeface="Microsoft YaHei"/>
-                <a:ea typeface="Microsoft YaHei"/>
-                <a:cs typeface="Microsoft YaHei"/>
-              </a:rPr>
-              <a:t>04</a:t>
-            </a:r>
-            <a:endParaRPr sz="1650" b="1">
-              <a:solidFill>
-                <a:srgbClr val="AF753D"/>
-              </a:solidFill>
-              <a:latin typeface="Microsoft YaHei"/>
-              <a:ea typeface="Microsoft YaHei"/>
-              <a:cs typeface="Microsoft YaHei"/>
-            </a:endParaRPr>
-          </a:p>
-        </p:txBody>
-      </p:sp>
-      <p:sp>
-        <p:nvSpPr>
-          <p:cNvPr id="39" name="文本框 38">
-            <a:extLst xmlns:a="http://schemas.openxmlformats.org/drawingml/2006/main">
-              <a:ext uri="{FF2B5EF4-FFF2-40B4-BE49-F238E27FC236}">
-                <a16:creationId xmlns:a16="http://schemas.microsoft.com/office/drawing/2014/main" id="{CB5F29E2-4D6C-481D-822D-A2DEF0D699E8}"/>
-              </a:ext>
-            </a:extLst>
-          </p:cNvPr>
-          <p:cNvSpPr>
-            <a:spLocks xmlns:a="http://schemas.openxmlformats.org/drawingml/2006/main" noGrp="1"/>
-          </p:cNvSpPr>
-          <p:nvPr/>
-        </p:nvSpPr>
-        <p:spPr>
-          <a:xfrm xmlns:a="http://schemas.openxmlformats.org/drawingml/2006/main">
-            <a:off x="6867525" y="4090397"/>
-            <a:ext cx="4752232" cy="261938"/>
-          </a:xfrm>
-          <a:prstGeom xmlns:a="http://schemas.openxmlformats.org/drawingml/2006/main" prst="rect">
-            <a:avLst/>
-          </a:prstGeom>
-          <a:noFill xmlns:a="http://schemas.openxmlformats.org/drawingml/2006/main"/>
-        </p:spPr>
-        <p:txBody>
-          <a:bodyPr xmlns:a="http://schemas.openxmlformats.org/drawingml/2006/main" wrap="square" lIns="0" tIns="0" rIns="0" bIns="0" anchor="t">
-            <a:noAutofit/>
-          </a:bodyPr>
-          <a:lstStyle xmlns:a="http://schemas.openxmlformats.org/drawingml/2006/main"/>
-          <a:p xmlns:a="http://schemas.openxmlformats.org/drawingml/2006/main">
-            <a:pPr algn="l">
-              <a:lnSpc>
-                <a:spcPct val="104000"/>
-              </a:lnSpc>
-              <a:buNone/>
-            </a:pPr>
-            <a:r>
-              <a:rPr sz="1500" b="1">
-                <a:solidFill>
-                  <a:schemeClr val="tx2">
-                    <a:lumMod val="4356"/>
-                    <a:lumOff val="95644"/>
-                  </a:schemeClr>
-                </a:solidFill>
-                <a:latin typeface="Microsoft YaHei"/>
-                <a:ea typeface="Microsoft YaHei"/>
-                <a:cs typeface="Microsoft YaHei"/>
-              </a:rPr>
-              <a:t>决策｜只在同一 SKU 内比价，并输出证据</a:t>
-            </a:r>
-            <a:endParaRPr sz="1500" b="1">
-              <a:solidFill>
-                <a:schemeClr val="tx2">
-                  <a:lumMod val="4356"/>
-                  <a:lumOff val="95644"/>
-                </a:schemeClr>
-              </a:solidFill>
-              <a:latin typeface="Microsoft YaHei"/>
-              <a:ea typeface="Microsoft YaHei"/>
-              <a:cs typeface="Microsoft YaHei"/>
-            </a:endParaRPr>
-          </a:p>
-        </p:txBody>
-      </p:sp>
-      <p:sp>
-        <p:nvSpPr>
-          <p:cNvPr id="43" name="任意多边形 42">
-            <a:extLst xmlns:a="http://schemas.openxmlformats.org/drawingml/2006/main">
-              <a:ext uri="{FF2B5EF4-FFF2-40B4-BE49-F238E27FC236}">
-                <a16:creationId xmlns:a16="http://schemas.microsoft.com/office/drawing/2014/main" id="{DB33CBCD-20E4-42C6-B272-B809C76CA4F3}"/>
-              </a:ext>
-            </a:extLst>
-          </p:cNvPr>
-          <p:cNvSpPr>
-            <a:spLocks xmlns:a="http://schemas.openxmlformats.org/drawingml/2006/main" noGrp="1"/>
-          </p:cNvSpPr>
-          <p:nvPr/>
-        </p:nvSpPr>
-        <p:spPr>
-          <a:xfrm xmlns:a="http://schemas.openxmlformats.org/drawingml/2006/main">
-            <a:off x="571500" y="5621020"/>
-            <a:ext cx="11049000" cy="666750"/>
-          </a:xfrm>
-          <a:custGeom xmlns:a="http://schemas.openxmlformats.org/drawingml/2006/main">
-            <a:gdLst>
-              <a:gd name="sw" fmla="*/ 1 w 17400"/>
-              <a:gd name="sh" fmla="*/ 1 h 1050"/>
-              <a:gd name="mins" fmla="min sw sh"/>
-              <a:gd name="dsw" fmla="+- 0 sw mins"/>
-              <a:gd name="dsh" fmla="+- 0 sh mins"/>
-              <a:gd name="p0x0" fmla="*/ 120 w 17400"/>
-              <a:gd name="p0y0" fmla="*/ 0 h 1050"/>
-              <a:gd name="p0x1" fmla="*/ 17280 w 17400"/>
-              <a:gd name="p0y1" fmla="*/ 0 h 1050"/>
-              <a:gd name="p0x2" fmla="*/ 17346 w 17400"/>
-              <a:gd name="p0y2" fmla="*/ 0 h 1050"/>
-              <a:gd name="p0x3" fmla="*/ 17400 w 17400"/>
-              <a:gd name="p0y3" fmla="*/ 53 h 1050"/>
-              <a:gd name="p0x4" fmla="*/ 17400 w 17400"/>
-              <a:gd name="p0y4" fmla="*/ 120 h 1050"/>
-              <a:gd name="p0x5" fmla="*/ 17400 w 17400"/>
-              <a:gd name="p0y5" fmla="*/ 930 h 1050"/>
-              <a:gd name="p0x6" fmla="*/ 17400 w 17400"/>
-              <a:gd name="p0y6" fmla="*/ 996 h 1050"/>
-              <a:gd name="p0x7" fmla="*/ 17346 w 17400"/>
-              <a:gd name="p0y7" fmla="*/ 1050 h 1050"/>
-              <a:gd name="p0x8" fmla="*/ 17280 w 17400"/>
-              <a:gd name="p0y8" fmla="*/ 1050 h 1050"/>
-              <a:gd name="p0x9" fmla="*/ 120 w 17400"/>
-              <a:gd name="p0y9" fmla="*/ 1050 h 1050"/>
-              <a:gd name="p0x10" fmla="*/ 53 w 17400"/>
-              <a:gd name="p0y10" fmla="*/ 1050 h 1050"/>
-              <a:gd name="p0x11" fmla="*/ 0 w 17400"/>
-              <a:gd name="p0y11" fmla="*/ 996 h 1050"/>
-              <a:gd name="p0x12" fmla="*/ 0 w 17400"/>
-              <a:gd name="p0y12" fmla="*/ 930 h 1050"/>
-              <a:gd name="p0x13" fmla="*/ 0 w 17400"/>
-              <a:gd name="p0y13" fmla="*/ 120 h 1050"/>
-              <a:gd name="p0x14" fmla="*/ 0 w 17400"/>
-              <a:gd name="p0y14" fmla="*/ 53 h 1050"/>
-              <a:gd name="p0x15" fmla="*/ 53 w 17400"/>
-              <a:gd name="p0y15" fmla="*/ 0 h 1050"/>
-              <a:gd name="p0x16" fmla="*/ 120 w 17400"/>
-              <a:gd name="p0y16" fmla="*/ 0 h 1050"/>
-            </a:gdLst>
-            <a:pathLst>
-              <a:path w="0" h="0">
-                <a:moveTo>
-                  <a:pt x="0" y="0"/>
-                </a:moveTo>
-                <a:lnTo>
-                  <a:pt x="0" y="0"/>
-                </a:lnTo>
-                <a:cubicBezTo>
-                  <a:pt x="0" y="0"/>
-                  <a:pt x="0" y="0"/>
-                  <a:pt x="0" y="0"/>
-                </a:cubicBezTo>
-                <a:lnTo>
-                  <a:pt x="0" y="0"/>
-                </a:lnTo>
-                <a:cubicBezTo>
-                  <a:pt x="0" y="0"/>
-                  <a:pt x="0" y="0"/>
-                  <a:pt x="0" y="0"/>
-                </a:cubicBezTo>
-                <a:lnTo>
-                  <a:pt x="0" y="0"/>
-                </a:lnTo>
-                <a:cubicBezTo>
-                  <a:pt x="0" y="0"/>
-                  <a:pt x="0" y="0"/>
-                  <a:pt x="0" y="0"/>
-                </a:cubicBezTo>
-                <a:lnTo>
-                  <a:pt x="0" y="0"/>
-                </a:lnTo>
-                <a:cubicBezTo>
-                  <a:pt x="0" y="0"/>
-                  <a:pt x="0" y="0"/>
-                  <a:pt x="0" y="0"/>
-                </a:cubicBezTo>
-                <a:close/>
-              </a:path>
-            </a:pathLst>
-          </a:custGeom>
-          <a:solidFill xmlns:a="http://schemas.openxmlformats.org/drawingml/2006/main">
-            <a:schemeClr val="accent1">
-              <a:lumMod val="69069"/>
-            </a:schemeClr>
-          </a:solidFill>
-          <a:ln xmlns:a="http://schemas.openxmlformats.org/drawingml/2006/main">
-            <a:noFill/>
-          </a:ln>
-          <a:effectLst xmlns:a="http://schemas.openxmlformats.org/drawingml/2006/main">
-            <a:outerShdw blurRad="142875" algn="ctr" rotWithShape="0">
-              <a:schemeClr val="accent2">
-                <a:alpha val="12157"/>
-              </a:schemeClr>
-            </a:outerShdw>
-          </a:effectLst>
-        </p:spPr>
-        <p:style>
-          <a:lnRef xmlns:a="http://schemas.openxmlformats.org/drawingml/2006/main" idx="2">
-            <a:schemeClr val="accent1">
-              <a:lumMod val="75000"/>
-            </a:schemeClr>
-          </a:lnRef>
-          <a:fillRef xmlns:a="http://schemas.openxmlformats.org/drawingml/2006/main" idx="1">
-            <a:schemeClr val="accent1"/>
-          </a:fillRef>
-          <a:effectRef xmlns:a="http://schemas.openxmlformats.org/drawingml/2006/main" idx="0">
-            <a:srgbClr val="FFFFFF"/>
-          </a:effectRef>
-          <a:fontRef xmlns:a="http://schemas.openxmlformats.org/drawingml/2006/main" idx="minor">
-            <a:schemeClr val="lt1"/>
-          </a:fontRef>
-        </p:style>
-        <p:txBody>
-          <a:bodyPr xmlns:a="http://schemas.openxmlformats.org/drawingml/2006/main" anchor="ctr"/>
-          <a:lstStyle xmlns:a="http://schemas.openxmlformats.org/drawingml/2006/main"/>
-          <a:p xmlns:a="http://schemas.openxmlformats.org/drawingml/2006/main">
-            <a:pPr algn="ctr">
-              <a:buNone/>
-            </a:pPr>
-            <a:endParaRPr/>
-          </a:p>
-        </p:txBody>
-      </p:sp>
-      <p:sp>
-        <p:nvSpPr>
-          <p:cNvPr id="44" name="文本框 43">
-            <a:extLst xmlns:a="http://schemas.openxmlformats.org/drawingml/2006/main">
-              <a:ext uri="{FF2B5EF4-FFF2-40B4-BE49-F238E27FC236}">
-                <a16:creationId xmlns:a16="http://schemas.microsoft.com/office/drawing/2014/main" id="{A788C6D1-B698-4EB4-A2E9-9A4526EB64C9}"/>
-              </a:ext>
-            </a:extLst>
-          </p:cNvPr>
-          <p:cNvSpPr>
-            <a:spLocks xmlns:a="http://schemas.openxmlformats.org/drawingml/2006/main" noGrp="1"/>
-          </p:cNvSpPr>
-          <p:nvPr/>
-        </p:nvSpPr>
-        <p:spPr>
-          <a:xfrm xmlns:a="http://schemas.openxmlformats.org/drawingml/2006/main">
-            <a:off x="762000" y="5796867"/>
-            <a:ext cx="3657829" cy="311468"/>
-          </a:xfrm>
-          <a:prstGeom xmlns:a="http://schemas.openxmlformats.org/drawingml/2006/main" prst="rect">
-            <a:avLst/>
-          </a:prstGeom>
-          <a:noFill xmlns:a="http://schemas.openxmlformats.org/drawingml/2006/main"/>
-        </p:spPr>
-        <p:txBody>
-          <a:bodyPr xmlns:a="http://schemas.openxmlformats.org/drawingml/2006/main" wrap="square" lIns="0" tIns="0" rIns="0" bIns="0" anchor="t">
-            <a:noAutofit/>
-          </a:bodyPr>
-          <a:lstStyle xmlns:a="http://schemas.openxmlformats.org/drawingml/2006/main"/>
-          <a:p xmlns:a="http://schemas.openxmlformats.org/drawingml/2006/main">
-            <a:pPr algn="l">
-              <a:lnSpc>
-                <a:spcPct val="104000"/>
-              </a:lnSpc>
-              <a:buNone/>
-            </a:pPr>
-            <a:r>
-              <a:rPr b="1">
-                <a:solidFill>
-                  <a:srgbClr val="FFFFFF"/>
-                </a:solidFill>
-                <a:latin typeface="Microsoft YaHei"/>
-                <a:ea typeface="Microsoft YaHei"/>
-                <a:cs typeface="Microsoft YaHei"/>
-              </a:rPr>
-              <a:t>先确定“同款”，再比较价格</a:t>
-            </a:r>
-            <a:endParaRPr b="1">
-              <a:solidFill>
-                <a:srgbClr val="FFFFFF"/>
-              </a:solidFill>
-              <a:latin typeface="Microsoft YaHei"/>
-              <a:ea typeface="Microsoft YaHei"/>
-              <a:cs typeface="Microsoft YaHei"/>
-            </a:endParaRPr>
-          </a:p>
-        </p:txBody>
-      </p:sp>
-    </p:spTree>
-    <p:extLst>
-      <p:ext uri="{BB962C8B-B14F-4D97-AF65-F5344CB8AC3E}">
-        <p14:creationId xmlns:p14="http://schemas.microsoft.com/office/powerpoint/2010/main" val="28428897"/>
-      </p:ext>
-    </p:extLst>
-  </p:cSld>
-</p:sld>
-</file>
-
 <file path=ppt/theme/theme1.xml><?xml version="1.0" encoding="utf-8"?>
 <a:theme xmlns:a="http://schemas.openxmlformats.org/drawingml/2006/main" name="商务风黑金色通用模板">
   <a:themeElements>

</xml_diff>